<commit_message>
Update Persian deck: B Titr/B Nazanin fonts, add presenter names
Switch from Tahoma to B Titr (headings) and B Nazanin (body) for
a more elegant Persian typography. Add presenter names on the title
slide: Parsa Ghorbanali, Matin Fahimi, Amirhossein Shahkhajeh.

Co-Authored-By: Claude Opus 4.6 <noreply@anthropic.com>
Claude-Session: https://claude.ai/code/session_01VwAEL1gh5GSVVNQtLSuyYj
</commit_message>
<xml_diff>
--- a/Commercial-Companies-Iran.pptx
+++ b/Commercial-Companies-Iran.pptx
@@ -116,52 +116,52 @@
   <p:extLst>
     <p:ext uri="{521415D9-36F7-43E2-AB2F-B90AF26B5E84}">
       <p14:sectionLst xmlns:p14="http://schemas.microsoft.com/office/powerpoint/2010/main">
-        <p14:section name="Opening" id="{55cbdca0-be0b-b927-c98d-84d1ae740d72}">
+        <p14:section name="Opening" id="{cad6a1bd-7ba3-a1a1-cb0e-26223dc54f41}">
           <p14:sldIdLst>
             <p14:sldId id="256"/>
           </p14:sldIdLst>
         </p14:section>
-        <p14:section name="WhatIs" id="{a708c239-658f-bec7-d377-de69025d0747}">
+        <p14:section name="WhatIs" id="{1178d2fa-1673-7099-1b95-267acd5b4d4c}">
           <p14:sldIdLst>
             <p14:sldId id="257"/>
           </p14:sldIdLst>
         </p14:section>
-        <p14:section name="Overview" id="{c92b0d2a-cc1d-4903-40ec-cdf9b27a3316}">
+        <p14:section name="Overview" id="{e0350f92-ac01-9649-2fd2-9ef8e6178f79}">
           <p14:sldIdLst>
             <p14:sldId id="258"/>
           </p14:sldIdLst>
         </p14:section>
-        <p14:section name="SahamiAam" id="{8254e62f-ec33-14d1-416d-d53545828bb8}">
+        <p14:section name="SahamiAam" id="{b0a99f3c-ed77-6d67-b402-933364af3d1d}">
           <p14:sldIdLst>
             <p14:sldId id="259"/>
           </p14:sldIdLst>
         </p14:section>
-        <p14:section name="SahamiKhas" id="{10c327dc-3dbe-54fb-05e3-178d272bcb27}">
+        <p14:section name="SahamiKhas" id="{e3f09977-5b65-56ca-10ed-b47da9367872}">
           <p14:sldIdLst>
             <p14:sldId id="260"/>
           </p14:sldIdLst>
         </p14:section>
-        <p14:section name="Masooliyat" id="{9935c51e-2a53-e83d-5873-7d06904a45e9}">
+        <p14:section name="Masooliyat" id="{ba379a76-7197-69ac-3016-f4cb7796fd27}">
           <p14:sldIdLst>
             <p14:sldId id="261"/>
           </p14:sldIdLst>
         </p14:section>
-        <p14:section name="TazamoniNesbi" id="{a6c1193f-0c9c-6f5f-e105-8a14aa1d5cea}">
+        <p14:section name="TazamoniNesbi" id="{7662a102-9c98-49f6-c56d-08e848acb0ed}">
           <p14:sldIdLst>
             <p14:sldId id="262"/>
           </p14:sldIdLst>
         </p14:section>
-        <p14:section name="Taavoni" id="{d5d537e8-e1e1-262c-a9df-3e5388986ec1}">
+        <p14:section name="Taavoni" id="{83eb533b-62dd-aacd-678c-2a7b9be0acd2}">
           <p14:sldIdLst>
             <p14:sldId id="263"/>
           </p14:sldIdLst>
         </p14:section>
-        <p14:section name="Comparison" id="{842be798-5a4f-e972-7b4c-ebb1da709abc}">
+        <p14:section name="Comparison" id="{cfea10e3-962c-9dc4-fb1b-7e3a22d5268b}">
           <p14:sldIdLst>
             <p14:sldId id="264"/>
           </p14:sldIdLst>
         </p14:section>
-        <p14:section name="Close" id="{c8ba7484-c080-c1d4-1b51-08895bea13c7}">
+        <p14:section name="Close" id="{320aac8a-a190-cdc5-6c7a-63454f2cfc63}">
           <p14:sldIdLst>
             <p14:sldId id="265"/>
           </p14:sldIdLst>
@@ -2066,9 +2066,9 @@
                 <a:solidFill>
                   <a:srgbClr val="FFFFFF"/>
                 </a:solidFill>
-                <a:latin typeface="Tahoma" pitchFamily="34" charset="0"/>
-                <a:ea typeface="Tahoma" pitchFamily="34" charset="-122"/>
-                <a:cs typeface="Tahoma" pitchFamily="34" charset="-120"/>
+                <a:latin typeface="B Titr" pitchFamily="34" charset="0"/>
+                <a:ea typeface="B Titr" pitchFamily="34" charset="-122"/>
+                <a:cs typeface="B Titr" pitchFamily="34" charset="-120"/>
               </a:rPr>
               <a:t>انواع شرکت‌های تجاری</a:t>
             </a:r>
@@ -2105,9 +2105,9 @@
                 <a:solidFill>
                   <a:srgbClr val="2563EB"/>
                 </a:solidFill>
-                <a:latin typeface="Tahoma" pitchFamily="34" charset="0"/>
-                <a:ea typeface="Tahoma" pitchFamily="34" charset="-122"/>
-                <a:cs typeface="Tahoma" pitchFamily="34" charset="-120"/>
+                <a:latin typeface="B Titr" pitchFamily="34" charset="0"/>
+                <a:ea typeface="B Titr" pitchFamily="34" charset="-122"/>
+                <a:cs typeface="B Titr" pitchFamily="34" charset="-120"/>
               </a:rPr>
               <a:t>متداول در ایران</a:t>
             </a:r>
@@ -2167,9 +2167,9 @@
                 <a:solidFill>
                   <a:srgbClr val="64748B"/>
                 </a:solidFill>
-                <a:latin typeface="Tahoma" pitchFamily="34" charset="0"/>
-                <a:ea typeface="Tahoma" pitchFamily="34" charset="-122"/>
-                <a:cs typeface="Tahoma" pitchFamily="34" charset="-120"/>
+                <a:latin typeface="B Nazanin" pitchFamily="34" charset="0"/>
+                <a:ea typeface="B Nazanin" pitchFamily="34" charset="-122"/>
+                <a:cs typeface="B Nazanin" pitchFamily="34" charset="-120"/>
               </a:rPr>
               <a:t>بررسی ساختار، ویژگی‌ها و کاربرد شرکت‌های تجاری در حقوق تجارت ایران</a:t>
             </a:r>
@@ -2206,9 +2206,9 @@
                 <a:solidFill>
                   <a:srgbClr val="64748B"/>
                 </a:solidFill>
-                <a:latin typeface="Tahoma" pitchFamily="34" charset="0"/>
-                <a:ea typeface="Tahoma" pitchFamily="34" charset="-122"/>
-                <a:cs typeface="Tahoma" pitchFamily="34" charset="-120"/>
+                <a:latin typeface="B Nazanin" pitchFamily="34" charset="0"/>
+                <a:ea typeface="B Nazanin" pitchFamily="34" charset="-122"/>
+                <a:cs typeface="B Nazanin" pitchFamily="34" charset="-120"/>
               </a:rPr>
               <a:t>درس کارآفرینی  ◈  دانشکده مهندسی کامپیوتر</a:t>
             </a:r>
@@ -2218,60 +2218,14 @@
       </p:sp>
       <p:sp>
         <p:nvSpPr>
-          <p:cNvPr id="11" name="c3-6bg"/>
-          <p:cNvSpPr/>
-          <p:nvPr/>
-        </p:nvSpPr>
-        <p:spPr>
-          <a:xfrm>
-            <a:off x="5623560" y="5029200"/>
-            <a:ext cx="411480" cy="411480"/>
-          </a:xfrm>
-          <a:prstGeom prst="ellipse">
-            <a:avLst/>
-          </a:prstGeom>
-          <a:solidFill>
-            <a:srgbClr val="2563EB">
-              <a:alpha val="30000"/>
-            </a:srgbClr>
-          </a:solidFill>
-          <a:ln/>
-        </p:spPr>
-      </p:sp>
-      <p:pic>
-        <p:nvPicPr>
-          <p:cNvPr id="12" name="c3-6ic" descr="preencoded.png">    </p:cNvPr>
-          <p:cNvPicPr>
-            <a:picLocks noChangeAspect="1"/>
-          </p:cNvPicPr>
-          <p:nvPr/>
-        </p:nvPicPr>
-        <p:blipFill>
-          <a:blip r:embed="rId1"/>
-          <a:stretch>
-            <a:fillRect/>
-          </a:stretch>
-        </p:blipFill>
-        <p:spPr>
-          <a:xfrm>
-            <a:off x="5705856" y="5111496"/>
-            <a:ext cx="246888" cy="246888"/>
-          </a:xfrm>
-          <a:prstGeom prst="rect">
-            <a:avLst/>
-          </a:prstGeom>
-        </p:spPr>
-      </p:pic>
-      <p:sp>
-        <p:nvSpPr>
-          <p:cNvPr id="13" name="c3-7"/>
+          <p:cNvPr id="11" name="c3-6"/>
           <p:cNvSpPr txBox="1"/>
           <p:nvPr/>
         </p:nvSpPr>
         <p:spPr>
           <a:xfrm>
-            <a:off x="731520" y="5577840"/>
-            <a:ext cx="10698480" cy="365760"/>
+            <a:off x="731520" y="4937760"/>
+            <a:ext cx="10698480" cy="320040"/>
           </a:xfrm>
           <a:prstGeom prst="rect">
             <a:avLst/>
@@ -2291,13 +2245,52 @@
                 <a:solidFill>
                   <a:srgbClr val="64748B"/>
                 </a:solidFill>
-                <a:latin typeface="Tahoma" pitchFamily="34" charset="0"/>
-                <a:ea typeface="Tahoma" pitchFamily="34" charset="-122"/>
-                <a:cs typeface="Tahoma" pitchFamily="34" charset="-120"/>
+                <a:latin typeface="B Nazanin" pitchFamily="34" charset="0"/>
+                <a:ea typeface="B Nazanin" pitchFamily="34" charset="-122"/>
+                <a:cs typeface="B Nazanin" pitchFamily="34" charset="-120"/>
               </a:rPr>
-              <a:t>پاییز ۱۴۰۵</a:t>
+              <a:t>ارائه‌دهندگان:</a:t>
             </a:r>
             <a:endParaRPr lang="en-US" sz="1300" dirty="0"/>
+          </a:p>
+        </p:txBody>
+      </p:sp>
+      <p:sp>
+        <p:nvSpPr>
+          <p:cNvPr id="12" name="c3-7"/>
+          <p:cNvSpPr txBox="1"/>
+          <p:nvPr/>
+        </p:nvSpPr>
+        <p:spPr>
+          <a:xfrm>
+            <a:off x="731520" y="5303520"/>
+            <a:ext cx="10698480" cy="457200"/>
+          </a:xfrm>
+          <a:prstGeom prst="rect">
+            <a:avLst/>
+          </a:prstGeom>
+          <a:noFill/>
+          <a:ln/>
+        </p:spPr>
+        <p:txBody>
+          <a:bodyPr wrap="square" lIns="0" tIns="0" rIns="0" bIns="0" rtlCol="0" anchor="ctr"/>
+          <a:lstStyle/>
+          <a:p>
+            <a:pPr rtl="1" algn="ctr" indent="0" marL="0">
+              <a:buNone/>
+            </a:pPr>
+            <a:r>
+              <a:rPr lang="en-US" sz="1800" dirty="0">
+                <a:solidFill>
+                  <a:srgbClr val="FFFFFF"/>
+                </a:solidFill>
+                <a:latin typeface="B Nazanin" pitchFamily="34" charset="0"/>
+                <a:ea typeface="B Nazanin" pitchFamily="34" charset="-122"/>
+                <a:cs typeface="B Nazanin" pitchFamily="34" charset="-120"/>
+              </a:rPr>
+              <a:t>پارسا قربانعلی  ◈  متین فهیمی  ◈  امیرحسین شاه‌خواجه</a:t>
+            </a:r>
+            <a:endParaRPr lang="en-US" sz="1800" dirty="0"/>
           </a:p>
         </p:txBody>
       </p:sp>
@@ -2667,7 +2660,7 @@
                                           </p:stCondLst>
                                         </p:cTn>
                                         <p:tgtEl>
-                                          <p:spTgt spid="13"/>
+                                          <p:spTgt spid="12"/>
                                         </p:tgtEl>
                                         <p:attrNameLst>
                                           <p:attrName>style.visibility</p:attrName>
@@ -2680,50 +2673,6 @@
                                     <p:animEffect transition="in" filter="fade">
                                       <p:cBhvr>
                                         <p:cTn id="33" dur="500"/>
-                                        <p:tgtEl>
-                                          <p:spTgt spid="13"/>
-                                        </p:tgtEl>
-                                      </p:cBhvr>
-                                    </p:animEffect>
-                                  </p:childTnLst>
-                                </p:cTn>
-                              </p:par>
-                            </p:childTnLst>
-                          </p:cTn>
-                        </p:par>
-                        <p:par>
-                          <p:cTn id="34" fill="hold">
-                            <p:stCondLst>
-                              <p:cond delay="0"/>
-                            </p:stCondLst>
-                            <p:childTnLst>
-                              <p:par>
-                                <p:cTn id="35" presetID="10" presetClass="entr" presetSubtype="0" fill="hold" grpId="0" nodeType="withEffect">
-                                  <p:stCondLst>
-                                    <p:cond delay="0"/>
-                                  </p:stCondLst>
-                                  <p:childTnLst>
-                                    <p:set>
-                                      <p:cBhvr>
-                                        <p:cTn id="36" dur="1" fill="hold">
-                                          <p:stCondLst>
-                                            <p:cond delay="0"/>
-                                          </p:stCondLst>
-                                        </p:cTn>
-                                        <p:tgtEl>
-                                          <p:spTgt spid="12"/>
-                                        </p:tgtEl>
-                                        <p:attrNameLst>
-                                          <p:attrName>style.visibility</p:attrName>
-                                        </p:attrNameLst>
-                                      </p:cBhvr>
-                                      <p:to>
-                                        <p:strVal val="visible"/>
-                                      </p:to>
-                                    </p:set>
-                                    <p:animEffect transition="in" filter="fade">
-                                      <p:cBhvr>
-                                        <p:cTn id="37" dur="500"/>
                                         <p:tgtEl>
                                           <p:spTgt spid="12"/>
                                         </p:tgtEl>
@@ -2766,7 +2715,6 @@
       <p:bldP spid="9" grpId="0"/>
       <p:bldP spid="10" grpId="0"/>
       <p:bldP spid="11" grpId="0"/>
-      <p:bldP spid="13" grpId="0"/>
       <p:bldP spid="12" grpId="0"/>
     </p:bldLst>
   </p:timing>
@@ -2927,9 +2875,9 @@
                 <a:solidFill>
                   <a:srgbClr val="FFFFFF"/>
                 </a:solidFill>
-                <a:latin typeface="Tahoma" pitchFamily="34" charset="0"/>
-                <a:ea typeface="Tahoma" pitchFamily="34" charset="-122"/>
-                <a:cs typeface="Tahoma" pitchFamily="34" charset="-120"/>
+                <a:latin typeface="B Titr" pitchFamily="34" charset="0"/>
+                <a:ea typeface="B Titr" pitchFamily="34" charset="-122"/>
+                <a:cs typeface="B Titr" pitchFamily="34" charset="-120"/>
               </a:rPr>
               <a:t>جمع‌بندی و نکات کلیدی</a:t>
             </a:r>
@@ -3015,9 +2963,9 @@
                 <a:solidFill>
                   <a:srgbClr val="FFFFFF"/>
                 </a:solidFill>
-                <a:latin typeface="Tahoma" pitchFamily="34" charset="0"/>
-                <a:ea typeface="Tahoma" pitchFamily="34" charset="-122"/>
-                <a:cs typeface="Tahoma" pitchFamily="34" charset="-120"/>
+                <a:latin typeface="B Nazanin" pitchFamily="34" charset="0"/>
+                <a:ea typeface="B Nazanin" pitchFamily="34" charset="-122"/>
+                <a:cs typeface="B Nazanin" pitchFamily="34" charset="-120"/>
               </a:rPr>
               <a:t>۱</a:t>
             </a:r>
@@ -3057,9 +3005,9 @@
                 <a:solidFill>
                   <a:srgbClr val="FFFFFF"/>
                 </a:solidFill>
-                <a:latin typeface="Tahoma" pitchFamily="34" charset="0"/>
-                <a:ea typeface="Tahoma" pitchFamily="34" charset="-122"/>
-                <a:cs typeface="Tahoma" pitchFamily="34" charset="-120"/>
+                <a:latin typeface="B Nazanin" pitchFamily="34" charset="0"/>
+                <a:ea typeface="B Nazanin" pitchFamily="34" charset="-122"/>
+                <a:cs typeface="B Nazanin" pitchFamily="34" charset="-120"/>
               </a:rPr>
               <a:t>انتخاب نوع شرکت باید با توجه به نوع فعالیت، میزان سرمایه و تعداد شرکا باشد</a:t>
             </a:r>
@@ -3145,9 +3093,9 @@
                 <a:solidFill>
                   <a:srgbClr val="FFFFFF"/>
                 </a:solidFill>
-                <a:latin typeface="Tahoma" pitchFamily="34" charset="0"/>
-                <a:ea typeface="Tahoma" pitchFamily="34" charset="-122"/>
-                <a:cs typeface="Tahoma" pitchFamily="34" charset="-120"/>
+                <a:latin typeface="B Nazanin" pitchFamily="34" charset="0"/>
+                <a:ea typeface="B Nazanin" pitchFamily="34" charset="-122"/>
+                <a:cs typeface="B Nazanin" pitchFamily="34" charset="-120"/>
               </a:rPr>
               <a:t>۲</a:t>
             </a:r>
@@ -3187,9 +3135,9 @@
                 <a:solidFill>
                   <a:srgbClr val="FFFFFF"/>
                 </a:solidFill>
-                <a:latin typeface="Tahoma" pitchFamily="34" charset="0"/>
-                <a:ea typeface="Tahoma" pitchFamily="34" charset="-122"/>
-                <a:cs typeface="Tahoma" pitchFamily="34" charset="-120"/>
+                <a:latin typeface="B Nazanin" pitchFamily="34" charset="0"/>
+                <a:ea typeface="B Nazanin" pitchFamily="34" charset="-122"/>
+                <a:cs typeface="B Nazanin" pitchFamily="34" charset="-120"/>
               </a:rPr>
               <a:t>سهامی خاص و مسئولیت محدود محبوب‌ترین و عملی‌ترین گزینه‌ها هستند</a:t>
             </a:r>
@@ -3275,9 +3223,9 @@
                 <a:solidFill>
                   <a:srgbClr val="FFFFFF"/>
                 </a:solidFill>
-                <a:latin typeface="Tahoma" pitchFamily="34" charset="0"/>
-                <a:ea typeface="Tahoma" pitchFamily="34" charset="-122"/>
-                <a:cs typeface="Tahoma" pitchFamily="34" charset="-120"/>
+                <a:latin typeface="B Nazanin" pitchFamily="34" charset="0"/>
+                <a:ea typeface="B Nazanin" pitchFamily="34" charset="-122"/>
+                <a:cs typeface="B Nazanin" pitchFamily="34" charset="-120"/>
               </a:rPr>
               <a:t>۳</a:t>
             </a:r>
@@ -3317,9 +3265,9 @@
                 <a:solidFill>
                   <a:srgbClr val="FFFFFF"/>
                 </a:solidFill>
-                <a:latin typeface="Tahoma" pitchFamily="34" charset="0"/>
-                <a:ea typeface="Tahoma" pitchFamily="34" charset="-122"/>
-                <a:cs typeface="Tahoma" pitchFamily="34" charset="-120"/>
+                <a:latin typeface="B Nazanin" pitchFamily="34" charset="0"/>
+                <a:ea typeface="B Nazanin" pitchFamily="34" charset="-122"/>
+                <a:cs typeface="B Nazanin" pitchFamily="34" charset="-120"/>
               </a:rPr>
               <a:t>هرچه مسئولیت شرکا بیشتر باشد ← ریسک بالاتر ولی اعتبار بیشتر</a:t>
             </a:r>
@@ -3405,9 +3353,9 @@
                 <a:solidFill>
                   <a:srgbClr val="FFFFFF"/>
                 </a:solidFill>
-                <a:latin typeface="Tahoma" pitchFamily="34" charset="0"/>
-                <a:ea typeface="Tahoma" pitchFamily="34" charset="-122"/>
-                <a:cs typeface="Tahoma" pitchFamily="34" charset="-120"/>
+                <a:latin typeface="B Nazanin" pitchFamily="34" charset="0"/>
+                <a:ea typeface="B Nazanin" pitchFamily="34" charset="-122"/>
+                <a:cs typeface="B Nazanin" pitchFamily="34" charset="-120"/>
               </a:rPr>
               <a:t>۴</a:t>
             </a:r>
@@ -3447,9 +3395,9 @@
                 <a:solidFill>
                   <a:srgbClr val="FFFFFF"/>
                 </a:solidFill>
-                <a:latin typeface="Tahoma" pitchFamily="34" charset="0"/>
-                <a:ea typeface="Tahoma" pitchFamily="34" charset="-122"/>
-                <a:cs typeface="Tahoma" pitchFamily="34" charset="-120"/>
+                <a:latin typeface="B Nazanin" pitchFamily="34" charset="0"/>
+                <a:ea typeface="B Nazanin" pitchFamily="34" charset="-122"/>
+                <a:cs typeface="B Nazanin" pitchFamily="34" charset="-120"/>
               </a:rPr>
               <a:t>برای کارآفرینی، سهامی خاص را به عنوان اولین گزینه در نظر بگیرید</a:t>
             </a:r>
@@ -3486,9 +3434,9 @@
                 <a:solidFill>
                   <a:srgbClr val="FFFFFF"/>
                 </a:solidFill>
-                <a:latin typeface="Tahoma" pitchFamily="34" charset="0"/>
-                <a:ea typeface="Tahoma" pitchFamily="34" charset="-122"/>
-                <a:cs typeface="Tahoma" pitchFamily="34" charset="-120"/>
+                <a:latin typeface="B Titr" pitchFamily="34" charset="0"/>
+                <a:ea typeface="B Titr" pitchFamily="34" charset="-122"/>
+                <a:cs typeface="B Titr" pitchFamily="34" charset="-120"/>
               </a:rPr>
               <a:t>با تشکر از توجه شما</a:t>
             </a:r>
@@ -4530,9 +4478,9 @@
                 <a:solidFill>
                   <a:srgbClr val="1E293B"/>
                 </a:solidFill>
-                <a:latin typeface="Tahoma" pitchFamily="34" charset="0"/>
-                <a:ea typeface="Tahoma" pitchFamily="34" charset="-122"/>
-                <a:cs typeface="Tahoma" pitchFamily="34" charset="-120"/>
+                <a:latin typeface="B Titr" pitchFamily="34" charset="0"/>
+                <a:ea typeface="B Titr" pitchFamily="34" charset="-122"/>
+                <a:cs typeface="B Titr" pitchFamily="34" charset="-120"/>
               </a:rPr>
               <a:t>شرکت تجاری چیست؟</a:t>
             </a:r>
@@ -4598,9 +4546,9 @@
                 <a:solidFill>
                   <a:srgbClr val="2563EB"/>
                 </a:solidFill>
-                <a:latin typeface="Tahoma" pitchFamily="34" charset="0"/>
-                <a:ea typeface="Tahoma" pitchFamily="34" charset="-122"/>
-                <a:cs typeface="Tahoma" pitchFamily="34" charset="-120"/>
+                <a:latin typeface="B Nazanin" pitchFamily="34" charset="0"/>
+                <a:ea typeface="B Nazanin" pitchFamily="34" charset="-122"/>
+                <a:cs typeface="B Nazanin" pitchFamily="34" charset="-120"/>
               </a:rPr>
               <a:t>تعریف ساده:</a:t>
             </a:r>
@@ -4640,9 +4588,9 @@
                 <a:solidFill>
                   <a:srgbClr val="1E293B"/>
                 </a:solidFill>
-                <a:latin typeface="Tahoma" pitchFamily="34" charset="0"/>
-                <a:ea typeface="Tahoma" pitchFamily="34" charset="-122"/>
-                <a:cs typeface="Tahoma" pitchFamily="34" charset="-120"/>
+                <a:latin typeface="B Nazanin" pitchFamily="34" charset="0"/>
+                <a:ea typeface="B Nazanin" pitchFamily="34" charset="-122"/>
+                <a:cs typeface="B Nazanin" pitchFamily="34" charset="-120"/>
               </a:rPr>
               <a:t>وقتی دو یا چند نفر پول یا مهارتشون رو کنار هم بذارن و با هم یک فعالیت تجاری انجام بدن تا سود کنن، یک شرکت تجاری تشکیل دادن.</a:t>
             </a:r>
@@ -4728,9 +4676,9 @@
                 <a:solidFill>
                   <a:srgbClr val="2563EB"/>
                 </a:solidFill>
-                <a:latin typeface="Tahoma" pitchFamily="34" charset="0"/>
-                <a:ea typeface="Tahoma" pitchFamily="34" charset="-122"/>
-                <a:cs typeface="Tahoma" pitchFamily="34" charset="-120"/>
+                <a:latin typeface="B Titr" pitchFamily="34" charset="0"/>
+                <a:ea typeface="B Titr" pitchFamily="34" charset="-122"/>
+                <a:cs typeface="B Titr" pitchFamily="34" charset="-120"/>
               </a:rPr>
               <a:t>۹۰٪</a:t>
             </a:r>
@@ -4770,9 +4718,9 @@
                 <a:solidFill>
                   <a:srgbClr val="64748B"/>
                 </a:solidFill>
-                <a:latin typeface="Tahoma" pitchFamily="34" charset="0"/>
-                <a:ea typeface="Tahoma" pitchFamily="34" charset="-122"/>
-                <a:cs typeface="Tahoma" pitchFamily="34" charset="-120"/>
+                <a:latin typeface="B Nazanin" pitchFamily="34" charset="0"/>
+                <a:ea typeface="B Nazanin" pitchFamily="34" charset="-122"/>
+                <a:cs typeface="B Nazanin" pitchFamily="34" charset="-120"/>
               </a:rPr>
               <a:t>محبوب‌ترین‌ها:</a:t>
             </a:r>
@@ -4790,9 +4738,9 @@
                 <a:solidFill>
                   <a:srgbClr val="64748B"/>
                 </a:solidFill>
-                <a:latin typeface="Tahoma" pitchFamily="34" charset="0"/>
-                <a:ea typeface="Tahoma" pitchFamily="34" charset="-122"/>
-                <a:cs typeface="Tahoma" pitchFamily="34" charset="-120"/>
+                <a:latin typeface="B Nazanin" pitchFamily="34" charset="0"/>
+                <a:ea typeface="B Nazanin" pitchFamily="34" charset="-122"/>
+                <a:cs typeface="B Nazanin" pitchFamily="34" charset="-120"/>
               </a:rPr>
               <a:t>سهامی خاص و مسئولیت محدود</a:t>
             </a:r>
@@ -4878,9 +4826,9 @@
                 <a:solidFill>
                   <a:srgbClr val="7C3AED"/>
                 </a:solidFill>
-                <a:latin typeface="Tahoma" pitchFamily="34" charset="0"/>
-                <a:ea typeface="Tahoma" pitchFamily="34" charset="-122"/>
-                <a:cs typeface="Tahoma" pitchFamily="34" charset="-120"/>
+                <a:latin typeface="B Titr" pitchFamily="34" charset="0"/>
+                <a:ea typeface="B Titr" pitchFamily="34" charset="-122"/>
+                <a:cs typeface="B Titr" pitchFamily="34" charset="-120"/>
               </a:rPr>
               <a:t>۳</a:t>
             </a:r>
@@ -4920,9 +4868,9 @@
                 <a:solidFill>
                   <a:srgbClr val="64748B"/>
                 </a:solidFill>
-                <a:latin typeface="Tahoma" pitchFamily="34" charset="0"/>
-                <a:ea typeface="Tahoma" pitchFamily="34" charset="-122"/>
-                <a:cs typeface="Tahoma" pitchFamily="34" charset="-120"/>
+                <a:latin typeface="B Nazanin" pitchFamily="34" charset="0"/>
+                <a:ea typeface="B Nazanin" pitchFamily="34" charset="-122"/>
+                <a:cs typeface="B Nazanin" pitchFamily="34" charset="-120"/>
               </a:rPr>
               <a:t>عامل انتخاب:</a:t>
             </a:r>
@@ -4940,9 +4888,9 @@
                 <a:solidFill>
                   <a:srgbClr val="64748B"/>
                 </a:solidFill>
-                <a:latin typeface="Tahoma" pitchFamily="34" charset="0"/>
-                <a:ea typeface="Tahoma" pitchFamily="34" charset="-122"/>
-                <a:cs typeface="Tahoma" pitchFamily="34" charset="-120"/>
+                <a:latin typeface="B Nazanin" pitchFamily="34" charset="0"/>
+                <a:ea typeface="B Nazanin" pitchFamily="34" charset="-122"/>
+                <a:cs typeface="B Nazanin" pitchFamily="34" charset="-120"/>
               </a:rPr>
               <a:t>نوع کار، تعداد شرکا، سرمایه</a:t>
             </a:r>
@@ -5028,9 +4976,9 @@
                 <a:solidFill>
                   <a:srgbClr val="0891B2"/>
                 </a:solidFill>
-                <a:latin typeface="Tahoma" pitchFamily="34" charset="0"/>
-                <a:ea typeface="Tahoma" pitchFamily="34" charset="-122"/>
-                <a:cs typeface="Tahoma" pitchFamily="34" charset="-120"/>
+                <a:latin typeface="B Titr" pitchFamily="34" charset="0"/>
+                <a:ea typeface="B Titr" pitchFamily="34" charset="-122"/>
+                <a:cs typeface="B Titr" pitchFamily="34" charset="-120"/>
               </a:rPr>
               <a:t>۷</a:t>
             </a:r>
@@ -5070,9 +5018,9 @@
                 <a:solidFill>
                   <a:srgbClr val="64748B"/>
                 </a:solidFill>
-                <a:latin typeface="Tahoma" pitchFamily="34" charset="0"/>
-                <a:ea typeface="Tahoma" pitchFamily="34" charset="-122"/>
-                <a:cs typeface="Tahoma" pitchFamily="34" charset="-120"/>
+                <a:latin typeface="B Nazanin" pitchFamily="34" charset="0"/>
+                <a:ea typeface="B Nazanin" pitchFamily="34" charset="-122"/>
+                <a:cs typeface="B Nazanin" pitchFamily="34" charset="-120"/>
               </a:rPr>
               <a:t>نوع شرکت در</a:t>
             </a:r>
@@ -5090,9 +5038,9 @@
                 <a:solidFill>
                   <a:srgbClr val="64748B"/>
                 </a:solidFill>
-                <a:latin typeface="Tahoma" pitchFamily="34" charset="0"/>
-                <a:ea typeface="Tahoma" pitchFamily="34" charset="-122"/>
-                <a:cs typeface="Tahoma" pitchFamily="34" charset="-120"/>
+                <a:latin typeface="B Nazanin" pitchFamily="34" charset="0"/>
+                <a:ea typeface="B Nazanin" pitchFamily="34" charset="-122"/>
+                <a:cs typeface="B Nazanin" pitchFamily="34" charset="-120"/>
               </a:rPr>
               <a:t>قانون تجارت ماده ۲۰</a:t>
             </a:r>
@@ -5178,9 +5126,9 @@
                 <a:solidFill>
                   <a:srgbClr val="D97706"/>
                 </a:solidFill>
-                <a:latin typeface="Tahoma" pitchFamily="34" charset="0"/>
-                <a:ea typeface="Tahoma" pitchFamily="34" charset="-122"/>
-                <a:cs typeface="Tahoma" pitchFamily="34" charset="-120"/>
+                <a:latin typeface="B Titr" pitchFamily="34" charset="0"/>
+                <a:ea typeface="B Titr" pitchFamily="34" charset="-122"/>
+                <a:cs typeface="B Titr" pitchFamily="34" charset="-120"/>
               </a:rPr>
               <a:t>+۱</a:t>
             </a:r>
@@ -5220,9 +5168,9 @@
                 <a:solidFill>
                   <a:srgbClr val="64748B"/>
                 </a:solidFill>
-                <a:latin typeface="Tahoma" pitchFamily="34" charset="0"/>
-                <a:ea typeface="Tahoma" pitchFamily="34" charset="-122"/>
-                <a:cs typeface="Tahoma" pitchFamily="34" charset="-120"/>
+                <a:latin typeface="B Nazanin" pitchFamily="34" charset="0"/>
+                <a:ea typeface="B Nazanin" pitchFamily="34" charset="-122"/>
+                <a:cs typeface="B Nazanin" pitchFamily="34" charset="-120"/>
               </a:rPr>
               <a:t>شرکت تعاونی</a:t>
             </a:r>
@@ -5240,9 +5188,9 @@
                 <a:solidFill>
                   <a:srgbClr val="64748B"/>
                 </a:solidFill>
-                <a:latin typeface="Tahoma" pitchFamily="34" charset="0"/>
-                <a:ea typeface="Tahoma" pitchFamily="34" charset="-122"/>
-                <a:cs typeface="Tahoma" pitchFamily="34" charset="-120"/>
+                <a:latin typeface="B Nazanin" pitchFamily="34" charset="0"/>
+                <a:ea typeface="B Nazanin" pitchFamily="34" charset="-122"/>
+                <a:cs typeface="B Nazanin" pitchFamily="34" charset="-120"/>
               </a:rPr>
               <a:t>در قانون جداگانه</a:t>
             </a:r>
@@ -6509,9 +6457,9 @@
                 <a:solidFill>
                   <a:srgbClr val="1E293B"/>
                 </a:solidFill>
-                <a:latin typeface="Tahoma" pitchFamily="34" charset="0"/>
-                <a:ea typeface="Tahoma" pitchFamily="34" charset="-122"/>
-                <a:cs typeface="Tahoma" pitchFamily="34" charset="-120"/>
+                <a:latin typeface="B Titr" pitchFamily="34" charset="0"/>
+                <a:ea typeface="B Titr" pitchFamily="34" charset="-122"/>
+                <a:cs typeface="B Titr" pitchFamily="34" charset="-120"/>
               </a:rPr>
               <a:t>نمای کلی: انواع شرکت‌های تجاری ایران</a:t>
             </a:r>
@@ -6568,9 +6516,9 @@
                 <a:solidFill>
                   <a:srgbClr val="FFFFFF"/>
                 </a:solidFill>
-                <a:latin typeface="Tahoma" pitchFamily="34" charset="0"/>
-                <a:ea typeface="Tahoma" pitchFamily="34" charset="-122"/>
-                <a:cs typeface="Tahoma" pitchFamily="34" charset="-120"/>
+                <a:latin typeface="B Nazanin" pitchFamily="34" charset="0"/>
+                <a:ea typeface="B Nazanin" pitchFamily="34" charset="-122"/>
+                <a:cs typeface="B Nazanin" pitchFamily="34" charset="-120"/>
               </a:rPr>
               <a:t>۱</a:t>
             </a:r>
@@ -6636,9 +6584,9 @@
                 <a:solidFill>
                   <a:srgbClr val="1E293B"/>
                 </a:solidFill>
-                <a:latin typeface="Tahoma" pitchFamily="34" charset="0"/>
-                <a:ea typeface="Tahoma" pitchFamily="34" charset="-122"/>
-                <a:cs typeface="Tahoma" pitchFamily="34" charset="-120"/>
+                <a:latin typeface="B Nazanin" pitchFamily="34" charset="0"/>
+                <a:ea typeface="B Nazanin" pitchFamily="34" charset="-122"/>
+                <a:cs typeface="B Nazanin" pitchFamily="34" charset="-120"/>
               </a:rPr>
               <a:t>شرکت سهامی عام</a:t>
             </a:r>
@@ -6699,9 +6647,9 @@
                 <a:solidFill>
                   <a:srgbClr val="7C3AED"/>
                 </a:solidFill>
-                <a:latin typeface="Tahoma" pitchFamily="34" charset="0"/>
-                <a:ea typeface="Tahoma" pitchFamily="34" charset="-122"/>
-                <a:cs typeface="Tahoma" pitchFamily="34" charset="-120"/>
+                <a:latin typeface="B Nazanin" pitchFamily="34" charset="0"/>
+                <a:ea typeface="B Nazanin" pitchFamily="34" charset="-122"/>
+                <a:cs typeface="B Nazanin" pitchFamily="34" charset="-120"/>
               </a:rPr>
               <a:t>بورسی • سرمایه بزرگ</a:t>
             </a:r>
@@ -6758,9 +6706,9 @@
                 <a:solidFill>
                   <a:srgbClr val="FFFFFF"/>
                 </a:solidFill>
-                <a:latin typeface="Tahoma" pitchFamily="34" charset="0"/>
-                <a:ea typeface="Tahoma" pitchFamily="34" charset="-122"/>
-                <a:cs typeface="Tahoma" pitchFamily="34" charset="-120"/>
+                <a:latin typeface="B Nazanin" pitchFamily="34" charset="0"/>
+                <a:ea typeface="B Nazanin" pitchFamily="34" charset="-122"/>
+                <a:cs typeface="B Nazanin" pitchFamily="34" charset="-120"/>
               </a:rPr>
               <a:t>۲</a:t>
             </a:r>
@@ -6826,9 +6774,9 @@
                 <a:solidFill>
                   <a:srgbClr val="1E293B"/>
                 </a:solidFill>
-                <a:latin typeface="Tahoma" pitchFamily="34" charset="0"/>
-                <a:ea typeface="Tahoma" pitchFamily="34" charset="-122"/>
-                <a:cs typeface="Tahoma" pitchFamily="34" charset="-120"/>
+                <a:latin typeface="B Nazanin" pitchFamily="34" charset="0"/>
+                <a:ea typeface="B Nazanin" pitchFamily="34" charset="-122"/>
+                <a:cs typeface="B Nazanin" pitchFamily="34" charset="-120"/>
               </a:rPr>
               <a:t>شرکت سهامی خاص</a:t>
             </a:r>
@@ -6889,9 +6837,9 @@
                 <a:solidFill>
                   <a:srgbClr val="2563EB"/>
                 </a:solidFill>
-                <a:latin typeface="Tahoma" pitchFamily="34" charset="0"/>
-                <a:ea typeface="Tahoma" pitchFamily="34" charset="-122"/>
-                <a:cs typeface="Tahoma" pitchFamily="34" charset="-120"/>
+                <a:latin typeface="B Nazanin" pitchFamily="34" charset="0"/>
+                <a:ea typeface="B Nazanin" pitchFamily="34" charset="-122"/>
+                <a:cs typeface="B Nazanin" pitchFamily="34" charset="-120"/>
               </a:rPr>
               <a:t>محبوب‌ترین نوع شرکت</a:t>
             </a:r>
@@ -6948,9 +6896,9 @@
                 <a:solidFill>
                   <a:srgbClr val="FFFFFF"/>
                 </a:solidFill>
-                <a:latin typeface="Tahoma" pitchFamily="34" charset="0"/>
-                <a:ea typeface="Tahoma" pitchFamily="34" charset="-122"/>
-                <a:cs typeface="Tahoma" pitchFamily="34" charset="-120"/>
+                <a:latin typeface="B Nazanin" pitchFamily="34" charset="0"/>
+                <a:ea typeface="B Nazanin" pitchFamily="34" charset="-122"/>
+                <a:cs typeface="B Nazanin" pitchFamily="34" charset="-120"/>
               </a:rPr>
               <a:t>۳</a:t>
             </a:r>
@@ -7016,9 +6964,9 @@
                 <a:solidFill>
                   <a:srgbClr val="1E293B"/>
                 </a:solidFill>
-                <a:latin typeface="Tahoma" pitchFamily="34" charset="0"/>
-                <a:ea typeface="Tahoma" pitchFamily="34" charset="-122"/>
-                <a:cs typeface="Tahoma" pitchFamily="34" charset="-120"/>
+                <a:latin typeface="B Nazanin" pitchFamily="34" charset="0"/>
+                <a:ea typeface="B Nazanin" pitchFamily="34" charset="-122"/>
+                <a:cs typeface="B Nazanin" pitchFamily="34" charset="-120"/>
               </a:rPr>
               <a:t>شرکت مسئولیت محدود</a:t>
             </a:r>
@@ -7079,9 +7027,9 @@
                 <a:solidFill>
                   <a:srgbClr val="0891B2"/>
                 </a:solidFill>
-                <a:latin typeface="Tahoma" pitchFamily="34" charset="0"/>
-                <a:ea typeface="Tahoma" pitchFamily="34" charset="-122"/>
-                <a:cs typeface="Tahoma" pitchFamily="34" charset="-120"/>
+                <a:latin typeface="B Nazanin" pitchFamily="34" charset="0"/>
+                <a:ea typeface="B Nazanin" pitchFamily="34" charset="-122"/>
+                <a:cs typeface="B Nazanin" pitchFamily="34" charset="-120"/>
               </a:rPr>
               <a:t>مناسب کسب‌وکار کوچک</a:t>
             </a:r>
@@ -7138,9 +7086,9 @@
                 <a:solidFill>
                   <a:srgbClr val="FFFFFF"/>
                 </a:solidFill>
-                <a:latin typeface="Tahoma" pitchFamily="34" charset="0"/>
-                <a:ea typeface="Tahoma" pitchFamily="34" charset="-122"/>
-                <a:cs typeface="Tahoma" pitchFamily="34" charset="-120"/>
+                <a:latin typeface="B Nazanin" pitchFamily="34" charset="0"/>
+                <a:ea typeface="B Nazanin" pitchFamily="34" charset="-122"/>
+                <a:cs typeface="B Nazanin" pitchFamily="34" charset="-120"/>
               </a:rPr>
               <a:t>۴</a:t>
             </a:r>
@@ -7206,9 +7154,9 @@
                 <a:solidFill>
                   <a:srgbClr val="1E293B"/>
                 </a:solidFill>
-                <a:latin typeface="Tahoma" pitchFamily="34" charset="0"/>
-                <a:ea typeface="Tahoma" pitchFamily="34" charset="-122"/>
-                <a:cs typeface="Tahoma" pitchFamily="34" charset="-120"/>
+                <a:latin typeface="B Nazanin" pitchFamily="34" charset="0"/>
+                <a:ea typeface="B Nazanin" pitchFamily="34" charset="-122"/>
+                <a:cs typeface="B Nazanin" pitchFamily="34" charset="-120"/>
               </a:rPr>
               <a:t>شرکت تضامنی</a:t>
             </a:r>
@@ -7269,9 +7217,9 @@
                 <a:solidFill>
                   <a:srgbClr val="DC2626"/>
                 </a:solidFill>
-                <a:latin typeface="Tahoma" pitchFamily="34" charset="0"/>
-                <a:ea typeface="Tahoma" pitchFamily="34" charset="-122"/>
-                <a:cs typeface="Tahoma" pitchFamily="34" charset="-120"/>
+                <a:latin typeface="B Nazanin" pitchFamily="34" charset="0"/>
+                <a:ea typeface="B Nazanin" pitchFamily="34" charset="-122"/>
+                <a:cs typeface="B Nazanin" pitchFamily="34" charset="-120"/>
               </a:rPr>
               <a:t>مسئولیت نامحدود شرکا</a:t>
             </a:r>
@@ -7328,9 +7276,9 @@
                 <a:solidFill>
                   <a:srgbClr val="FFFFFF"/>
                 </a:solidFill>
-                <a:latin typeface="Tahoma" pitchFamily="34" charset="0"/>
-                <a:ea typeface="Tahoma" pitchFamily="34" charset="-122"/>
-                <a:cs typeface="Tahoma" pitchFamily="34" charset="-120"/>
+                <a:latin typeface="B Nazanin" pitchFamily="34" charset="0"/>
+                <a:ea typeface="B Nazanin" pitchFamily="34" charset="-122"/>
+                <a:cs typeface="B Nazanin" pitchFamily="34" charset="-120"/>
               </a:rPr>
               <a:t>۵</a:t>
             </a:r>
@@ -7396,9 +7344,9 @@
                 <a:solidFill>
                   <a:srgbClr val="1E293B"/>
                 </a:solidFill>
-                <a:latin typeface="Tahoma" pitchFamily="34" charset="0"/>
-                <a:ea typeface="Tahoma" pitchFamily="34" charset="-122"/>
-                <a:cs typeface="Tahoma" pitchFamily="34" charset="-120"/>
+                <a:latin typeface="B Nazanin" pitchFamily="34" charset="0"/>
+                <a:ea typeface="B Nazanin" pitchFamily="34" charset="-122"/>
+                <a:cs typeface="B Nazanin" pitchFamily="34" charset="-120"/>
               </a:rPr>
               <a:t>شرکت نسبی</a:t>
             </a:r>
@@ -7459,9 +7407,9 @@
                 <a:solidFill>
                   <a:srgbClr val="D97706"/>
                 </a:solidFill>
-                <a:latin typeface="Tahoma" pitchFamily="34" charset="0"/>
-                <a:ea typeface="Tahoma" pitchFamily="34" charset="-122"/>
-                <a:cs typeface="Tahoma" pitchFamily="34" charset="-120"/>
+                <a:latin typeface="B Nazanin" pitchFamily="34" charset="0"/>
+                <a:ea typeface="B Nazanin" pitchFamily="34" charset="-122"/>
+                <a:cs typeface="B Nazanin" pitchFamily="34" charset="-120"/>
               </a:rPr>
               <a:t>مسئولیت به نسبت سرمایه</a:t>
             </a:r>
@@ -7518,9 +7466,9 @@
                 <a:solidFill>
                   <a:srgbClr val="FFFFFF"/>
                 </a:solidFill>
-                <a:latin typeface="Tahoma" pitchFamily="34" charset="0"/>
-                <a:ea typeface="Tahoma" pitchFamily="34" charset="-122"/>
-                <a:cs typeface="Tahoma" pitchFamily="34" charset="-120"/>
+                <a:latin typeface="B Nazanin" pitchFamily="34" charset="0"/>
+                <a:ea typeface="B Nazanin" pitchFamily="34" charset="-122"/>
+                <a:cs typeface="B Nazanin" pitchFamily="34" charset="-120"/>
               </a:rPr>
               <a:t>۶</a:t>
             </a:r>
@@ -7586,9 +7534,9 @@
                 <a:solidFill>
                   <a:srgbClr val="1E293B"/>
                 </a:solidFill>
-                <a:latin typeface="Tahoma" pitchFamily="34" charset="0"/>
-                <a:ea typeface="Tahoma" pitchFamily="34" charset="-122"/>
-                <a:cs typeface="Tahoma" pitchFamily="34" charset="-120"/>
+                <a:latin typeface="B Nazanin" pitchFamily="34" charset="0"/>
+                <a:ea typeface="B Nazanin" pitchFamily="34" charset="-122"/>
+                <a:cs typeface="B Nazanin" pitchFamily="34" charset="-120"/>
               </a:rPr>
               <a:t>شرکت مختلط سهامی</a:t>
             </a:r>
@@ -7649,9 +7597,9 @@
                 <a:solidFill>
                   <a:srgbClr val="94A3B8"/>
                 </a:solidFill>
-                <a:latin typeface="Tahoma" pitchFamily="34" charset="0"/>
-                <a:ea typeface="Tahoma" pitchFamily="34" charset="-122"/>
-                <a:cs typeface="Tahoma" pitchFamily="34" charset="-120"/>
+                <a:latin typeface="B Nazanin" pitchFamily="34" charset="0"/>
+                <a:ea typeface="B Nazanin" pitchFamily="34" charset="-122"/>
+                <a:cs typeface="B Nazanin" pitchFamily="34" charset="-120"/>
               </a:rPr>
               <a:t>ترکیب سهامی و تضامنی</a:t>
             </a:r>
@@ -7708,9 +7656,9 @@
                 <a:solidFill>
                   <a:srgbClr val="FFFFFF"/>
                 </a:solidFill>
-                <a:latin typeface="Tahoma" pitchFamily="34" charset="0"/>
-                <a:ea typeface="Tahoma" pitchFamily="34" charset="-122"/>
-                <a:cs typeface="Tahoma" pitchFamily="34" charset="-120"/>
+                <a:latin typeface="B Nazanin" pitchFamily="34" charset="0"/>
+                <a:ea typeface="B Nazanin" pitchFamily="34" charset="-122"/>
+                <a:cs typeface="B Nazanin" pitchFamily="34" charset="-120"/>
               </a:rPr>
               <a:t>۷</a:t>
             </a:r>
@@ -7776,9 +7724,9 @@
                 <a:solidFill>
                   <a:srgbClr val="1E293B"/>
                 </a:solidFill>
-                <a:latin typeface="Tahoma" pitchFamily="34" charset="0"/>
-                <a:ea typeface="Tahoma" pitchFamily="34" charset="-122"/>
-                <a:cs typeface="Tahoma" pitchFamily="34" charset="-120"/>
+                <a:latin typeface="B Nazanin" pitchFamily="34" charset="0"/>
+                <a:ea typeface="B Nazanin" pitchFamily="34" charset="-122"/>
+                <a:cs typeface="B Nazanin" pitchFamily="34" charset="-120"/>
               </a:rPr>
               <a:t>شرکت مختلط غیرسهامی</a:t>
             </a:r>
@@ -7839,9 +7787,9 @@
                 <a:solidFill>
                   <a:srgbClr val="94A3B8"/>
                 </a:solidFill>
-                <a:latin typeface="Tahoma" pitchFamily="34" charset="0"/>
-                <a:ea typeface="Tahoma" pitchFamily="34" charset="-122"/>
-                <a:cs typeface="Tahoma" pitchFamily="34" charset="-120"/>
+                <a:latin typeface="B Nazanin" pitchFamily="34" charset="0"/>
+                <a:ea typeface="B Nazanin" pitchFamily="34" charset="-122"/>
+                <a:cs typeface="B Nazanin" pitchFamily="34" charset="-120"/>
               </a:rPr>
               <a:t>ترکیب غیرسهامی</a:t>
             </a:r>
@@ -7898,9 +7846,9 @@
                 <a:solidFill>
                   <a:srgbClr val="FFFFFF"/>
                 </a:solidFill>
-                <a:latin typeface="Tahoma" pitchFamily="34" charset="0"/>
-                <a:ea typeface="Tahoma" pitchFamily="34" charset="-122"/>
-                <a:cs typeface="Tahoma" pitchFamily="34" charset="-120"/>
+                <a:latin typeface="B Nazanin" pitchFamily="34" charset="0"/>
+                <a:ea typeface="B Nazanin" pitchFamily="34" charset="-122"/>
+                <a:cs typeface="B Nazanin" pitchFamily="34" charset="-120"/>
               </a:rPr>
               <a:t>۸</a:t>
             </a:r>
@@ -7966,9 +7914,9 @@
                 <a:solidFill>
                   <a:srgbClr val="1E293B"/>
                 </a:solidFill>
-                <a:latin typeface="Tahoma" pitchFamily="34" charset="0"/>
-                <a:ea typeface="Tahoma" pitchFamily="34" charset="-122"/>
-                <a:cs typeface="Tahoma" pitchFamily="34" charset="-120"/>
+                <a:latin typeface="B Nazanin" pitchFamily="34" charset="0"/>
+                <a:ea typeface="B Nazanin" pitchFamily="34" charset="-122"/>
+                <a:cs typeface="B Nazanin" pitchFamily="34" charset="-120"/>
               </a:rPr>
               <a:t>شرکت تعاونی</a:t>
             </a:r>
@@ -8029,9 +7977,9 @@
                 <a:solidFill>
                   <a:srgbClr val="059669"/>
                 </a:solidFill>
-                <a:latin typeface="Tahoma" pitchFamily="34" charset="0"/>
-                <a:ea typeface="Tahoma" pitchFamily="34" charset="-122"/>
-                <a:cs typeface="Tahoma" pitchFamily="34" charset="-120"/>
+                <a:latin typeface="B Nazanin" pitchFamily="34" charset="0"/>
+                <a:ea typeface="B Nazanin" pitchFamily="34" charset="-122"/>
+                <a:cs typeface="B Nazanin" pitchFamily="34" charset="-120"/>
               </a:rPr>
               <a:t>مشارکتی • غیرانتفاعی</a:t>
             </a:r>
@@ -8092,9 +8040,9 @@
                 <a:solidFill>
                   <a:srgbClr val="D97706"/>
                 </a:solidFill>
-                <a:latin typeface="Tahoma" pitchFamily="34" charset="0"/>
-                <a:ea typeface="Tahoma" pitchFamily="34" charset="-122"/>
-                <a:cs typeface="Tahoma" pitchFamily="34" charset="-120"/>
+                <a:latin typeface="B Nazanin" pitchFamily="34" charset="0"/>
+                <a:ea typeface="B Nazanin" pitchFamily="34" charset="-122"/>
+                <a:cs typeface="B Nazanin" pitchFamily="34" charset="-120"/>
               </a:rPr>
               <a:t>★  در عمل بیش از ۹۰٪ شرکت‌ها «سهامی خاص» یا «مسئولیت محدود» هستند</a:t>
             </a:r>
@@ -10765,9 +10713,9 @@
                 <a:solidFill>
                   <a:srgbClr val="1E293B"/>
                 </a:solidFill>
-                <a:latin typeface="Tahoma" pitchFamily="34" charset="0"/>
-                <a:ea typeface="Tahoma" pitchFamily="34" charset="-122"/>
-                <a:cs typeface="Tahoma" pitchFamily="34" charset="-120"/>
+                <a:latin typeface="B Titr" pitchFamily="34" charset="0"/>
+                <a:ea typeface="B Titr" pitchFamily="34" charset="-122"/>
+                <a:cs typeface="B Titr" pitchFamily="34" charset="-120"/>
               </a:rPr>
               <a:t>شرکت سهامی عام</a:t>
             </a:r>
@@ -10804,9 +10752,9 @@
                 <a:solidFill>
                   <a:srgbClr val="64748B"/>
                 </a:solidFill>
-                <a:latin typeface="Tahoma" pitchFamily="34" charset="0"/>
-                <a:ea typeface="Tahoma" pitchFamily="34" charset="-122"/>
-                <a:cs typeface="Tahoma" pitchFamily="34" charset="-120"/>
+                <a:latin typeface="B Nazanin" pitchFamily="34" charset="0"/>
+                <a:ea typeface="B Nazanin" pitchFamily="34" charset="-122"/>
+                <a:cs typeface="B Nazanin" pitchFamily="34" charset="-120"/>
               </a:rPr>
               <a:t>بزرگ‌ترین نوع شرکت تجاری  ◈  سهام قابل معامله در بورس</a:t>
             </a:r>
@@ -10843,9 +10791,9 @@
                 <a:solidFill>
                   <a:srgbClr val="7C3AED"/>
                 </a:solidFill>
-                <a:latin typeface="Tahoma" pitchFamily="34" charset="0"/>
-                <a:ea typeface="Tahoma" pitchFamily="34" charset="-122"/>
-                <a:cs typeface="Tahoma" pitchFamily="34" charset="-120"/>
+                <a:latin typeface="B Nazanin" pitchFamily="34" charset="0"/>
+                <a:ea typeface="B Nazanin" pitchFamily="34" charset="-122"/>
+                <a:cs typeface="B Nazanin" pitchFamily="34" charset="-120"/>
               </a:rPr>
               <a:t>ویژگی‌های اصلی</a:t>
             </a:r>
@@ -10889,9 +10837,9 @@
                 <a:solidFill>
                   <a:srgbClr val="1E293B"/>
                 </a:solidFill>
-                <a:latin typeface="Tahoma" pitchFamily="34" charset="0"/>
-                <a:ea typeface="Tahoma" pitchFamily="34" charset="-122"/>
-                <a:cs typeface="Tahoma" pitchFamily="34" charset="-120"/>
+                <a:latin typeface="B Nazanin" pitchFamily="34" charset="0"/>
+                <a:ea typeface="B Nazanin" pitchFamily="34" charset="-122"/>
+                <a:cs typeface="B Nazanin" pitchFamily="34" charset="-120"/>
               </a:rPr>
               <a:t>سرمایه از طریق فروش سهام به عموم مردم تأمین می‌شود</a:t>
             </a:r>
@@ -10913,9 +10861,9 @@
                 <a:solidFill>
                   <a:srgbClr val="1E293B"/>
                 </a:solidFill>
-                <a:latin typeface="Tahoma" pitchFamily="34" charset="0"/>
-                <a:ea typeface="Tahoma" pitchFamily="34" charset="-122"/>
-                <a:cs typeface="Tahoma" pitchFamily="34" charset="-120"/>
+                <a:latin typeface="B Nazanin" pitchFamily="34" charset="0"/>
+                <a:ea typeface="B Nazanin" pitchFamily="34" charset="-122"/>
+                <a:cs typeface="B Nazanin" pitchFamily="34" charset="-120"/>
               </a:rPr>
               <a:t>حداقل ۵ سهامدار و حداقل سرمایه بالا</a:t>
             </a:r>
@@ -10937,9 +10885,9 @@
                 <a:solidFill>
                   <a:srgbClr val="1E293B"/>
                 </a:solidFill>
-                <a:latin typeface="Tahoma" pitchFamily="34" charset="0"/>
-                <a:ea typeface="Tahoma" pitchFamily="34" charset="-122"/>
-                <a:cs typeface="Tahoma" pitchFamily="34" charset="-120"/>
+                <a:latin typeface="B Nazanin" pitchFamily="34" charset="0"/>
+                <a:ea typeface="B Nazanin" pitchFamily="34" charset="-122"/>
+                <a:cs typeface="B Nazanin" pitchFamily="34" charset="-120"/>
               </a:rPr>
               <a:t>سهام در بورس اوراق بهادار قابل خرید و فروش است</a:t>
             </a:r>
@@ -10961,9 +10909,9 @@
                 <a:solidFill>
                   <a:srgbClr val="1E293B"/>
                 </a:solidFill>
-                <a:latin typeface="Tahoma" pitchFamily="34" charset="0"/>
-                <a:ea typeface="Tahoma" pitchFamily="34" charset="-122"/>
-                <a:cs typeface="Tahoma" pitchFamily="34" charset="-120"/>
+                <a:latin typeface="B Nazanin" pitchFamily="34" charset="0"/>
+                <a:ea typeface="B Nazanin" pitchFamily="34" charset="-122"/>
+                <a:cs typeface="B Nazanin" pitchFamily="34" charset="-120"/>
               </a:rPr>
               <a:t>مسئولیت سهامداران فقط به اندازه سهامشان</a:t>
             </a:r>
@@ -10985,9 +10933,9 @@
                 <a:solidFill>
                   <a:srgbClr val="1E293B"/>
                 </a:solidFill>
-                <a:latin typeface="Tahoma" pitchFamily="34" charset="0"/>
-                <a:ea typeface="Tahoma" pitchFamily="34" charset="-122"/>
-                <a:cs typeface="Tahoma" pitchFamily="34" charset="-120"/>
+                <a:latin typeface="B Nazanin" pitchFamily="34" charset="0"/>
+                <a:ea typeface="B Nazanin" pitchFamily="34" charset="-122"/>
+                <a:cs typeface="B Nazanin" pitchFamily="34" charset="-120"/>
               </a:rPr>
               <a:t>باید هیئت‌مدیره (حداقل ۵ نفر) و بازرس قانونی داشته باشد</a:t>
             </a:r>
@@ -11053,9 +11001,9 @@
                 <a:solidFill>
                   <a:srgbClr val="7C3AED"/>
                 </a:solidFill>
-                <a:latin typeface="Tahoma" pitchFamily="34" charset="0"/>
-                <a:ea typeface="Tahoma" pitchFamily="34" charset="-122"/>
-                <a:cs typeface="Tahoma" pitchFamily="34" charset="-120"/>
+                <a:latin typeface="B Nazanin" pitchFamily="34" charset="0"/>
+                <a:ea typeface="B Nazanin" pitchFamily="34" charset="-122"/>
+                <a:cs typeface="B Nazanin" pitchFamily="34" charset="-120"/>
               </a:rPr>
               <a:t>نمونه‌های واقعی</a:t>
             </a:r>
@@ -11092,9 +11040,9 @@
                 <a:solidFill>
                   <a:srgbClr val="1E293B"/>
                 </a:solidFill>
-                <a:latin typeface="Tahoma" pitchFamily="34" charset="0"/>
-                <a:ea typeface="Tahoma" pitchFamily="34" charset="-122"/>
-                <a:cs typeface="Tahoma" pitchFamily="34" charset="-120"/>
+                <a:latin typeface="B Nazanin" pitchFamily="34" charset="0"/>
+                <a:ea typeface="B Nazanin" pitchFamily="34" charset="-122"/>
+                <a:cs typeface="B Nazanin" pitchFamily="34" charset="-120"/>
               </a:rPr>
               <a:t>▸  ایران‌خودرو</a:t>
             </a:r>
@@ -11131,9 +11079,9 @@
                 <a:solidFill>
                   <a:srgbClr val="1E293B"/>
                 </a:solidFill>
-                <a:latin typeface="Tahoma" pitchFamily="34" charset="0"/>
-                <a:ea typeface="Tahoma" pitchFamily="34" charset="-122"/>
-                <a:cs typeface="Tahoma" pitchFamily="34" charset="-120"/>
+                <a:latin typeface="B Nazanin" pitchFamily="34" charset="0"/>
+                <a:ea typeface="B Nazanin" pitchFamily="34" charset="-122"/>
+                <a:cs typeface="B Nazanin" pitchFamily="34" charset="-120"/>
               </a:rPr>
               <a:t>▸  فولاد مبارکه اصفهان</a:t>
             </a:r>
@@ -11170,9 +11118,9 @@
                 <a:solidFill>
                   <a:srgbClr val="1E293B"/>
                 </a:solidFill>
-                <a:latin typeface="Tahoma" pitchFamily="34" charset="0"/>
-                <a:ea typeface="Tahoma" pitchFamily="34" charset="-122"/>
-                <a:cs typeface="Tahoma" pitchFamily="34" charset="-120"/>
+                <a:latin typeface="B Nazanin" pitchFamily="34" charset="0"/>
+                <a:ea typeface="B Nazanin" pitchFamily="34" charset="-122"/>
+                <a:cs typeface="B Nazanin" pitchFamily="34" charset="-120"/>
               </a:rPr>
               <a:t>▸  بانک ملت</a:t>
             </a:r>
@@ -11262,9 +11210,9 @@
                 <a:solidFill>
                   <a:srgbClr val="7C3AED"/>
                 </a:solidFill>
-                <a:latin typeface="Tahoma" pitchFamily="34" charset="0"/>
-                <a:ea typeface="Tahoma" pitchFamily="34" charset="-122"/>
-                <a:cs typeface="Tahoma" pitchFamily="34" charset="-120"/>
+                <a:latin typeface="B Nazanin" pitchFamily="34" charset="0"/>
+                <a:ea typeface="B Nazanin" pitchFamily="34" charset="-122"/>
+                <a:cs typeface="B Nazanin" pitchFamily="34" charset="-120"/>
               </a:rPr>
               <a:t>نکته کلیدی:</a:t>
             </a:r>
@@ -11301,9 +11249,9 @@
                 <a:solidFill>
                   <a:srgbClr val="1E293B"/>
                 </a:solidFill>
-                <a:latin typeface="Tahoma" pitchFamily="34" charset="0"/>
-                <a:ea typeface="Tahoma" pitchFamily="34" charset="-122"/>
-                <a:cs typeface="Tahoma" pitchFamily="34" charset="-120"/>
+                <a:latin typeface="B Nazanin" pitchFamily="34" charset="0"/>
+                <a:ea typeface="B Nazanin" pitchFamily="34" charset="-122"/>
+                <a:cs typeface="B Nazanin" pitchFamily="34" charset="-120"/>
               </a:rPr>
               <a:t>مناسب شرکت‌های بزرگ که نیاز به جذب سرمایه از مردم دارند. ثبت و مدیریت پیچیده‌تر از سایر انواع.</a:t>
             </a:r>
@@ -12240,9 +12188,9 @@
                 <a:solidFill>
                   <a:srgbClr val="FFFFFF"/>
                 </a:solidFill>
-                <a:latin typeface="Tahoma" pitchFamily="34" charset="0"/>
-                <a:ea typeface="Tahoma" pitchFamily="34" charset="-122"/>
-                <a:cs typeface="Tahoma" pitchFamily="34" charset="-120"/>
+                <a:latin typeface="B Nazanin" pitchFamily="34" charset="0"/>
+                <a:ea typeface="B Nazanin" pitchFamily="34" charset="-122"/>
+                <a:cs typeface="B Nazanin" pitchFamily="34" charset="-120"/>
               </a:rPr>
               <a:t>★  محبوب‌ترین نوع شرکت در ایران</a:t>
             </a:r>
@@ -12325,9 +12273,9 @@
                 <a:solidFill>
                   <a:srgbClr val="1E293B"/>
                 </a:solidFill>
-                <a:latin typeface="Tahoma" pitchFamily="34" charset="0"/>
-                <a:ea typeface="Tahoma" pitchFamily="34" charset="-122"/>
-                <a:cs typeface="Tahoma" pitchFamily="34" charset="-120"/>
+                <a:latin typeface="B Titr" pitchFamily="34" charset="0"/>
+                <a:ea typeface="B Titr" pitchFamily="34" charset="-122"/>
+                <a:cs typeface="B Titr" pitchFamily="34" charset="-120"/>
               </a:rPr>
               <a:t>شرکت سهامی خاص</a:t>
             </a:r>
@@ -12364,9 +12312,9 @@
                 <a:solidFill>
                   <a:srgbClr val="2563EB"/>
                 </a:solidFill>
-                <a:latin typeface="Tahoma" pitchFamily="34" charset="0"/>
-                <a:ea typeface="Tahoma" pitchFamily="34" charset="-122"/>
-                <a:cs typeface="Tahoma" pitchFamily="34" charset="-120"/>
+                <a:latin typeface="B Nazanin" pitchFamily="34" charset="0"/>
+                <a:ea typeface="B Nazanin" pitchFamily="34" charset="-122"/>
+                <a:cs typeface="B Nazanin" pitchFamily="34" charset="-120"/>
               </a:rPr>
               <a:t>ویژگی‌های اصلی</a:t>
             </a:r>
@@ -12410,9 +12358,9 @@
                 <a:solidFill>
                   <a:srgbClr val="1E293B"/>
                 </a:solidFill>
-                <a:latin typeface="Tahoma" pitchFamily="34" charset="0"/>
-                <a:ea typeface="Tahoma" pitchFamily="34" charset="-122"/>
-                <a:cs typeface="Tahoma" pitchFamily="34" charset="-120"/>
+                <a:latin typeface="B Nazanin" pitchFamily="34" charset="0"/>
+                <a:ea typeface="B Nazanin" pitchFamily="34" charset="-122"/>
+                <a:cs typeface="B Nazanin" pitchFamily="34" charset="-120"/>
               </a:rPr>
               <a:t>حداقل ۳ سهامدار نیاز دارد</a:t>
             </a:r>
@@ -12434,9 +12382,9 @@
                 <a:solidFill>
                   <a:srgbClr val="1E293B"/>
                 </a:solidFill>
-                <a:latin typeface="Tahoma" pitchFamily="34" charset="0"/>
-                <a:ea typeface="Tahoma" pitchFamily="34" charset="-122"/>
-                <a:cs typeface="Tahoma" pitchFamily="34" charset="-120"/>
+                <a:latin typeface="B Nazanin" pitchFamily="34" charset="0"/>
+                <a:ea typeface="B Nazanin" pitchFamily="34" charset="-122"/>
+                <a:cs typeface="B Nazanin" pitchFamily="34" charset="-120"/>
               </a:rPr>
               <a:t>سهام فقط بین شرکا قابل انتقال است (بورسی نیست)</a:t>
             </a:r>
@@ -12458,9 +12406,9 @@
                 <a:solidFill>
                   <a:srgbClr val="1E293B"/>
                 </a:solidFill>
-                <a:latin typeface="Tahoma" pitchFamily="34" charset="0"/>
-                <a:ea typeface="Tahoma" pitchFamily="34" charset="-122"/>
-                <a:cs typeface="Tahoma" pitchFamily="34" charset="-120"/>
+                <a:latin typeface="B Nazanin" pitchFamily="34" charset="0"/>
+                <a:ea typeface="B Nazanin" pitchFamily="34" charset="-122"/>
+                <a:cs typeface="B Nazanin" pitchFamily="34" charset="-120"/>
               </a:rPr>
               <a:t>مسئولیت سهامداران محدود به میزان سهامشان</a:t>
             </a:r>
@@ -12482,9 +12430,9 @@
                 <a:solidFill>
                   <a:srgbClr val="1E293B"/>
                 </a:solidFill>
-                <a:latin typeface="Tahoma" pitchFamily="34" charset="0"/>
-                <a:ea typeface="Tahoma" pitchFamily="34" charset="-122"/>
-                <a:cs typeface="Tahoma" pitchFamily="34" charset="-120"/>
+                <a:latin typeface="B Nazanin" pitchFamily="34" charset="0"/>
+                <a:ea typeface="B Nazanin" pitchFamily="34" charset="-122"/>
+                <a:cs typeface="B Nazanin" pitchFamily="34" charset="-120"/>
               </a:rPr>
               <a:t>تشریفات اداری ساده‌تر و انعطاف‌پذیری بالا</a:t>
             </a:r>
@@ -12550,9 +12498,9 @@
                 <a:solidFill>
                   <a:srgbClr val="2563EB"/>
                 </a:solidFill>
-                <a:latin typeface="Tahoma" pitchFamily="34" charset="0"/>
-                <a:ea typeface="Tahoma" pitchFamily="34" charset="-122"/>
-                <a:cs typeface="Tahoma" pitchFamily="34" charset="-120"/>
+                <a:latin typeface="B Nazanin" pitchFamily="34" charset="0"/>
+                <a:ea typeface="B Nazanin" pitchFamily="34" charset="-122"/>
+                <a:cs typeface="B Nazanin" pitchFamily="34" charset="-120"/>
               </a:rPr>
               <a:t>تفاوت با سهامی عام</a:t>
             </a:r>
@@ -12592,9 +12540,9 @@
                 <a:solidFill>
                   <a:srgbClr val="1E293B"/>
                 </a:solidFill>
-                <a:latin typeface="Tahoma" pitchFamily="34" charset="0"/>
-                <a:ea typeface="Tahoma" pitchFamily="34" charset="-122"/>
-                <a:cs typeface="Tahoma" pitchFamily="34" charset="-120"/>
+                <a:latin typeface="B Nazanin" pitchFamily="34" charset="0"/>
+                <a:ea typeface="B Nazanin" pitchFamily="34" charset="-122"/>
+                <a:cs typeface="B Nazanin" pitchFamily="34" charset="-120"/>
               </a:rPr>
               <a:t>✦  سهام به عموم فروخته نمی‌شود</a:t>
             </a:r>
@@ -12634,9 +12582,9 @@
                 <a:solidFill>
                   <a:srgbClr val="1E293B"/>
                 </a:solidFill>
-                <a:latin typeface="Tahoma" pitchFamily="34" charset="0"/>
-                <a:ea typeface="Tahoma" pitchFamily="34" charset="-122"/>
-                <a:cs typeface="Tahoma" pitchFamily="34" charset="-120"/>
+                <a:latin typeface="B Nazanin" pitchFamily="34" charset="0"/>
+                <a:ea typeface="B Nazanin" pitchFamily="34" charset="-122"/>
+                <a:cs typeface="B Nazanin" pitchFamily="34" charset="-120"/>
               </a:rPr>
               <a:t>✦  تعداد سهامداران کمتر (۳ به جای ۵)</a:t>
             </a:r>
@@ -12676,9 +12624,9 @@
                 <a:solidFill>
                   <a:srgbClr val="1E293B"/>
                 </a:solidFill>
-                <a:latin typeface="Tahoma" pitchFamily="34" charset="0"/>
-                <a:ea typeface="Tahoma" pitchFamily="34" charset="-122"/>
-                <a:cs typeface="Tahoma" pitchFamily="34" charset="-120"/>
+                <a:latin typeface="B Nazanin" pitchFamily="34" charset="0"/>
+                <a:ea typeface="B Nazanin" pitchFamily="34" charset="-122"/>
+                <a:cs typeface="B Nazanin" pitchFamily="34" charset="-120"/>
               </a:rPr>
               <a:t>✦  سرمایه اولیه کمتری لازم دارد</a:t>
             </a:r>
@@ -12718,9 +12666,9 @@
                 <a:solidFill>
                   <a:srgbClr val="1E293B"/>
                 </a:solidFill>
-                <a:latin typeface="Tahoma" pitchFamily="34" charset="0"/>
-                <a:ea typeface="Tahoma" pitchFamily="34" charset="-122"/>
-                <a:cs typeface="Tahoma" pitchFamily="34" charset="-120"/>
+                <a:latin typeface="B Nazanin" pitchFamily="34" charset="0"/>
+                <a:ea typeface="B Nazanin" pitchFamily="34" charset="-122"/>
+                <a:cs typeface="B Nazanin" pitchFamily="34" charset="-120"/>
               </a:rPr>
               <a:t>✦  بدون نیاز به بورس و پذیره‌نویسی</a:t>
             </a:r>
@@ -12779,9 +12727,9 @@
                 <a:solidFill>
                   <a:srgbClr val="FFFFFF"/>
                 </a:solidFill>
-                <a:latin typeface="Tahoma" pitchFamily="34" charset="0"/>
-                <a:ea typeface="Tahoma" pitchFamily="34" charset="-122"/>
-                <a:cs typeface="Tahoma" pitchFamily="34" charset="-120"/>
+                <a:latin typeface="B Nazanin" pitchFamily="34" charset="0"/>
+                <a:ea typeface="B Nazanin" pitchFamily="34" charset="-122"/>
+                <a:cs typeface="B Nazanin" pitchFamily="34" charset="-120"/>
               </a:rPr>
               <a:t>چرا انتخاب اول کارآفرینان است؟</a:t>
             </a:r>
@@ -12847,9 +12795,9 @@
                 <a:solidFill>
                   <a:srgbClr val="2563EB"/>
                 </a:solidFill>
-                <a:latin typeface="Tahoma" pitchFamily="34" charset="0"/>
-                <a:ea typeface="Tahoma" pitchFamily="34" charset="-122"/>
-                <a:cs typeface="Tahoma" pitchFamily="34" charset="-120"/>
+                <a:latin typeface="B Nazanin" pitchFamily="34" charset="0"/>
+                <a:ea typeface="B Nazanin" pitchFamily="34" charset="-122"/>
+                <a:cs typeface="B Nazanin" pitchFamily="34" charset="-120"/>
               </a:rPr>
               <a:t>ثبت آسان</a:t>
             </a:r>
@@ -12915,9 +12863,9 @@
                 <a:solidFill>
                   <a:srgbClr val="2563EB"/>
                 </a:solidFill>
-                <a:latin typeface="Tahoma" pitchFamily="34" charset="0"/>
-                <a:ea typeface="Tahoma" pitchFamily="34" charset="-122"/>
-                <a:cs typeface="Tahoma" pitchFamily="34" charset="-120"/>
+                <a:latin typeface="B Nazanin" pitchFamily="34" charset="0"/>
+                <a:ea typeface="B Nazanin" pitchFamily="34" charset="-122"/>
+                <a:cs typeface="B Nazanin" pitchFamily="34" charset="-120"/>
               </a:rPr>
               <a:t>هزینه کم</a:t>
             </a:r>
@@ -12983,9 +12931,9 @@
                 <a:solidFill>
                   <a:srgbClr val="2563EB"/>
                 </a:solidFill>
-                <a:latin typeface="Tahoma" pitchFamily="34" charset="0"/>
-                <a:ea typeface="Tahoma" pitchFamily="34" charset="-122"/>
-                <a:cs typeface="Tahoma" pitchFamily="34" charset="-120"/>
+                <a:latin typeface="B Nazanin" pitchFamily="34" charset="0"/>
+                <a:ea typeface="B Nazanin" pitchFamily="34" charset="-122"/>
+                <a:cs typeface="B Nazanin" pitchFamily="34" charset="-120"/>
               </a:rPr>
               <a:t>مدیریت ساده</a:t>
             </a:r>
@@ -13051,9 +12999,9 @@
                 <a:solidFill>
                   <a:srgbClr val="2563EB"/>
                 </a:solidFill>
-                <a:latin typeface="Tahoma" pitchFamily="34" charset="0"/>
-                <a:ea typeface="Tahoma" pitchFamily="34" charset="-122"/>
-                <a:cs typeface="Tahoma" pitchFamily="34" charset="-120"/>
+                <a:latin typeface="B Nazanin" pitchFamily="34" charset="0"/>
+                <a:ea typeface="B Nazanin" pitchFamily="34" charset="-122"/>
+                <a:cs typeface="B Nazanin" pitchFamily="34" charset="-120"/>
               </a:rPr>
               <a:t>مناسب استارتاپ‌ها</a:t>
             </a:r>
@@ -13119,9 +13067,9 @@
                 <a:solidFill>
                   <a:srgbClr val="2563EB"/>
                 </a:solidFill>
-                <a:latin typeface="Tahoma" pitchFamily="34" charset="0"/>
-                <a:ea typeface="Tahoma" pitchFamily="34" charset="-122"/>
-                <a:cs typeface="Tahoma" pitchFamily="34" charset="-120"/>
+                <a:latin typeface="B Nazanin" pitchFamily="34" charset="0"/>
+                <a:ea typeface="B Nazanin" pitchFamily="34" charset="-122"/>
+                <a:cs typeface="B Nazanin" pitchFamily="34" charset="-120"/>
               </a:rPr>
               <a:t>بدون نیاز به سرمایه بسیار بالا</a:t>
             </a:r>
@@ -14532,9 +14480,9 @@
                 <a:solidFill>
                   <a:srgbClr val="1E293B"/>
                 </a:solidFill>
-                <a:latin typeface="Tahoma" pitchFamily="34" charset="0"/>
-                <a:ea typeface="Tahoma" pitchFamily="34" charset="-122"/>
-                <a:cs typeface="Tahoma" pitchFamily="34" charset="-120"/>
+                <a:latin typeface="B Titr" pitchFamily="34" charset="0"/>
+                <a:ea typeface="B Titr" pitchFamily="34" charset="-122"/>
+                <a:cs typeface="B Titr" pitchFamily="34" charset="-120"/>
               </a:rPr>
               <a:t>شرکت با مسئولیت محدود</a:t>
             </a:r>
@@ -14571,9 +14519,9 @@
                 <a:solidFill>
                   <a:srgbClr val="64748B"/>
                 </a:solidFill>
-                <a:latin typeface="Tahoma" pitchFamily="34" charset="0"/>
-                <a:ea typeface="Tahoma" pitchFamily="34" charset="-122"/>
-                <a:cs typeface="Tahoma" pitchFamily="34" charset="-120"/>
+                <a:latin typeface="B Nazanin" pitchFamily="34" charset="0"/>
+                <a:ea typeface="B Nazanin" pitchFamily="34" charset="-122"/>
+                <a:cs typeface="B Nazanin" pitchFamily="34" charset="-120"/>
               </a:rPr>
               <a:t>ساده‌ترین نوع شرکت تجاری</a:t>
             </a:r>
@@ -14610,9 +14558,9 @@
                 <a:solidFill>
                   <a:srgbClr val="0891B2"/>
                 </a:solidFill>
-                <a:latin typeface="Tahoma" pitchFamily="34" charset="0"/>
-                <a:ea typeface="Tahoma" pitchFamily="34" charset="-122"/>
-                <a:cs typeface="Tahoma" pitchFamily="34" charset="-120"/>
+                <a:latin typeface="B Nazanin" pitchFamily="34" charset="0"/>
+                <a:ea typeface="B Nazanin" pitchFamily="34" charset="-122"/>
+                <a:cs typeface="B Nazanin" pitchFamily="34" charset="-120"/>
               </a:rPr>
               <a:t>ویژگی‌های اصلی</a:t>
             </a:r>
@@ -14656,9 +14604,9 @@
                 <a:solidFill>
                   <a:srgbClr val="1E293B"/>
                 </a:solidFill>
-                <a:latin typeface="Tahoma" pitchFamily="34" charset="0"/>
-                <a:ea typeface="Tahoma" pitchFamily="34" charset="-122"/>
-                <a:cs typeface="Tahoma" pitchFamily="34" charset="-120"/>
+                <a:latin typeface="B Nazanin" pitchFamily="34" charset="0"/>
+                <a:ea typeface="B Nazanin" pitchFamily="34" charset="-122"/>
+                <a:cs typeface="B Nazanin" pitchFamily="34" charset="-120"/>
               </a:rPr>
               <a:t>حداقل ۲ شریک نیاز دارد</a:t>
             </a:r>
@@ -14680,9 +14628,9 @@
                 <a:solidFill>
                   <a:srgbClr val="1E293B"/>
                 </a:solidFill>
-                <a:latin typeface="Tahoma" pitchFamily="34" charset="0"/>
-                <a:ea typeface="Tahoma" pitchFamily="34" charset="-122"/>
-                <a:cs typeface="Tahoma" pitchFamily="34" charset="-120"/>
+                <a:latin typeface="B Nazanin" pitchFamily="34" charset="0"/>
+                <a:ea typeface="B Nazanin" pitchFamily="34" charset="-122"/>
+                <a:cs typeface="B Nazanin" pitchFamily="34" charset="-120"/>
               </a:rPr>
               <a:t>حداقل سرمایه مشخصی ندارد</a:t>
             </a:r>
@@ -14704,9 +14652,9 @@
                 <a:solidFill>
                   <a:srgbClr val="1E293B"/>
                 </a:solidFill>
-                <a:latin typeface="Tahoma" pitchFamily="34" charset="0"/>
-                <a:ea typeface="Tahoma" pitchFamily="34" charset="-122"/>
-                <a:cs typeface="Tahoma" pitchFamily="34" charset="-120"/>
+                <a:latin typeface="B Nazanin" pitchFamily="34" charset="0"/>
+                <a:ea typeface="B Nazanin" pitchFamily="34" charset="-122"/>
+                <a:cs typeface="B Nazanin" pitchFamily="34" charset="-120"/>
               </a:rPr>
               <a:t>سهام ندارد — شرکا «سهم‌الشرکه» دارند</a:t>
             </a:r>
@@ -14728,9 +14676,9 @@
                 <a:solidFill>
                   <a:srgbClr val="1E293B"/>
                 </a:solidFill>
-                <a:latin typeface="Tahoma" pitchFamily="34" charset="0"/>
-                <a:ea typeface="Tahoma" pitchFamily="34" charset="-122"/>
-                <a:cs typeface="Tahoma" pitchFamily="34" charset="-120"/>
+                <a:latin typeface="B Nazanin" pitchFamily="34" charset="0"/>
+                <a:ea typeface="B Nazanin" pitchFamily="34" charset="-122"/>
+                <a:cs typeface="B Nazanin" pitchFamily="34" charset="-120"/>
               </a:rPr>
               <a:t>انتقال سهم‌الشرکه نیاز به موافقت اکثریت شرکا</a:t>
             </a:r>
@@ -14752,9 +14700,9 @@
                 <a:solidFill>
                   <a:srgbClr val="1E293B"/>
                 </a:solidFill>
-                <a:latin typeface="Tahoma" pitchFamily="34" charset="0"/>
-                <a:ea typeface="Tahoma" pitchFamily="34" charset="-122"/>
-                <a:cs typeface="Tahoma" pitchFamily="34" charset="-120"/>
+                <a:latin typeface="B Nazanin" pitchFamily="34" charset="0"/>
+                <a:ea typeface="B Nazanin" pitchFamily="34" charset="-122"/>
+                <a:cs typeface="B Nazanin" pitchFamily="34" charset="-120"/>
               </a:rPr>
               <a:t>مسئولیت فقط به اندازه سهم‌الشرکه</a:t>
             </a:r>
@@ -14820,9 +14768,9 @@
                 <a:solidFill>
                   <a:srgbClr val="0891B2"/>
                 </a:solidFill>
-                <a:latin typeface="Tahoma" pitchFamily="34" charset="0"/>
-                <a:ea typeface="Tahoma" pitchFamily="34" charset="-122"/>
-                <a:cs typeface="Tahoma" pitchFamily="34" charset="-120"/>
+                <a:latin typeface="B Nazanin" pitchFamily="34" charset="0"/>
+                <a:ea typeface="B Nazanin" pitchFamily="34" charset="-122"/>
+                <a:cs typeface="B Nazanin" pitchFamily="34" charset="-120"/>
               </a:rPr>
               <a:t>سهم‌الشرکه در مقابل سهام</a:t>
             </a:r>
@@ -14859,9 +14807,9 @@
                 <a:solidFill>
                   <a:srgbClr val="1E293B"/>
                 </a:solidFill>
-                <a:latin typeface="Tahoma" pitchFamily="34" charset="0"/>
-                <a:ea typeface="Tahoma" pitchFamily="34" charset="-122"/>
-                <a:cs typeface="Tahoma" pitchFamily="34" charset="-120"/>
+                <a:latin typeface="B Nazanin" pitchFamily="34" charset="0"/>
+                <a:ea typeface="B Nazanin" pitchFamily="34" charset="-122"/>
+                <a:cs typeface="B Nazanin" pitchFamily="34" charset="-120"/>
               </a:rPr>
               <a:t>سهام = ورقه‌ای که آزادانه خرید و فروش می‌شود</a:t>
             </a:r>
@@ -14924,9 +14872,9 @@
                 <a:solidFill>
                   <a:srgbClr val="1E293B"/>
                 </a:solidFill>
-                <a:latin typeface="Tahoma" pitchFamily="34" charset="0"/>
-                <a:ea typeface="Tahoma" pitchFamily="34" charset="-122"/>
-                <a:cs typeface="Tahoma" pitchFamily="34" charset="-120"/>
+                <a:latin typeface="B Nazanin" pitchFamily="34" charset="0"/>
+                <a:ea typeface="B Nazanin" pitchFamily="34" charset="-122"/>
+                <a:cs typeface="B Nazanin" pitchFamily="34" charset="-120"/>
               </a:rPr>
               <a:t>سهم‌الشرکه = ورقه ندارد، انتقال سخت‌تر و نیاز به موافقت شرکا</a:t>
             </a:r>
@@ -14987,9 +14935,9 @@
                 <a:solidFill>
                   <a:srgbClr val="0891B2"/>
                 </a:solidFill>
-                <a:latin typeface="Tahoma" pitchFamily="34" charset="0"/>
-                <a:ea typeface="Tahoma" pitchFamily="34" charset="-122"/>
-                <a:cs typeface="Tahoma" pitchFamily="34" charset="-120"/>
+                <a:latin typeface="B Nazanin" pitchFamily="34" charset="0"/>
+                <a:ea typeface="B Nazanin" pitchFamily="34" charset="-122"/>
+                <a:cs typeface="B Nazanin" pitchFamily="34" charset="-120"/>
               </a:rPr>
               <a:t>بهترین انتخاب برای: کسب‌وکارهای کوچک خانوادگی، مغازه‌ها، کارگاه‌ها</a:t>
             </a:r>
@@ -15055,9 +15003,9 @@
                 <a:solidFill>
                   <a:srgbClr val="64748B"/>
                 </a:solidFill>
-                <a:latin typeface="Tahoma" pitchFamily="34" charset="0"/>
-                <a:ea typeface="Tahoma" pitchFamily="34" charset="-122"/>
-                <a:cs typeface="Tahoma" pitchFamily="34" charset="-120"/>
+                <a:latin typeface="B Nazanin" pitchFamily="34" charset="0"/>
+                <a:ea typeface="B Nazanin" pitchFamily="34" charset="-122"/>
+                <a:cs typeface="B Nazanin" pitchFamily="34" charset="-120"/>
               </a:rPr>
               <a:t>تفاوت اصلی با سهامی خاص:  سهم‌الشرکه به جای سهام  |  حداقل ۲ نفر  |  انتقال مالکیت سخت‌تر</a:t>
             </a:r>
@@ -16018,9 +15966,9 @@
                 <a:solidFill>
                   <a:srgbClr val="1E293B"/>
                 </a:solidFill>
-                <a:latin typeface="Tahoma" pitchFamily="34" charset="0"/>
-                <a:ea typeface="Tahoma" pitchFamily="34" charset="-122"/>
-                <a:cs typeface="Tahoma" pitchFamily="34" charset="-120"/>
+                <a:latin typeface="B Titr" pitchFamily="34" charset="0"/>
+                <a:ea typeface="B Titr" pitchFamily="34" charset="-122"/>
+                <a:cs typeface="B Titr" pitchFamily="34" charset="-120"/>
               </a:rPr>
               <a:t>شرکت تضامنی و شرکت نسبی</a:t>
             </a:r>
@@ -16086,9 +16034,9 @@
                 <a:solidFill>
                   <a:srgbClr val="DC2626"/>
                 </a:solidFill>
-                <a:latin typeface="Tahoma" pitchFamily="34" charset="0"/>
-                <a:ea typeface="Tahoma" pitchFamily="34" charset="-122"/>
-                <a:cs typeface="Tahoma" pitchFamily="34" charset="-120"/>
+                <a:latin typeface="B Nazanin" pitchFamily="34" charset="0"/>
+                <a:ea typeface="B Nazanin" pitchFamily="34" charset="-122"/>
+                <a:cs typeface="B Nazanin" pitchFamily="34" charset="-120"/>
               </a:rPr>
               <a:t>شرکت تضامنی</a:t>
             </a:r>
@@ -16132,9 +16080,9 @@
                 <a:solidFill>
                   <a:srgbClr val="1E293B"/>
                 </a:solidFill>
-                <a:latin typeface="Tahoma" pitchFamily="34" charset="0"/>
-                <a:ea typeface="Tahoma" pitchFamily="34" charset="-122"/>
-                <a:cs typeface="Tahoma" pitchFamily="34" charset="-120"/>
+                <a:latin typeface="B Nazanin" pitchFamily="34" charset="0"/>
+                <a:ea typeface="B Nazanin" pitchFamily="34" charset="-122"/>
+                <a:cs typeface="B Nazanin" pitchFamily="34" charset="-120"/>
               </a:rPr>
               <a:t>شرکا مسئولیت نامحدود و تضامنی دارند</a:t>
             </a:r>
@@ -16156,9 +16104,9 @@
                 <a:solidFill>
                   <a:srgbClr val="1E293B"/>
                 </a:solidFill>
-                <a:latin typeface="Tahoma" pitchFamily="34" charset="0"/>
-                <a:ea typeface="Tahoma" pitchFamily="34" charset="-122"/>
-                <a:cs typeface="Tahoma" pitchFamily="34" charset="-120"/>
+                <a:latin typeface="B Nazanin" pitchFamily="34" charset="0"/>
+                <a:ea typeface="B Nazanin" pitchFamily="34" charset="-122"/>
+                <a:cs typeface="B Nazanin" pitchFamily="34" charset="-120"/>
               </a:rPr>
               <a:t>اگر شرکت نتونه بدهی بده، شرکا از جیب خودشون باید بدن</a:t>
             </a:r>
@@ -16180,9 +16128,9 @@
                 <a:solidFill>
                   <a:srgbClr val="1E293B"/>
                 </a:solidFill>
-                <a:latin typeface="Tahoma" pitchFamily="34" charset="0"/>
-                <a:ea typeface="Tahoma" pitchFamily="34" charset="-122"/>
-                <a:cs typeface="Tahoma" pitchFamily="34" charset="-120"/>
+                <a:latin typeface="B Nazanin" pitchFamily="34" charset="0"/>
+                <a:ea typeface="B Nazanin" pitchFamily="34" charset="-122"/>
+                <a:cs typeface="B Nazanin" pitchFamily="34" charset="-120"/>
               </a:rPr>
               <a:t>هر شریک مسئول تمام بدهی است نه فقط سهم خودش</a:t>
             </a:r>
@@ -16204,9 +16152,9 @@
                 <a:solidFill>
                   <a:srgbClr val="1E293B"/>
                 </a:solidFill>
-                <a:latin typeface="Tahoma" pitchFamily="34" charset="0"/>
-                <a:ea typeface="Tahoma" pitchFamily="34" charset="-122"/>
-                <a:cs typeface="Tahoma" pitchFamily="34" charset="-120"/>
+                <a:latin typeface="B Nazanin" pitchFamily="34" charset="0"/>
+                <a:ea typeface="B Nazanin" pitchFamily="34" charset="-122"/>
+                <a:cs typeface="B Nazanin" pitchFamily="34" charset="-120"/>
               </a:rPr>
               <a:t>بر پایه اعتماد کامل متقابل</a:t>
             </a:r>
@@ -16272,9 +16220,9 @@
                 <a:solidFill>
                   <a:srgbClr val="D97706"/>
                 </a:solidFill>
-                <a:latin typeface="Tahoma" pitchFamily="34" charset="0"/>
-                <a:ea typeface="Tahoma" pitchFamily="34" charset="-122"/>
-                <a:cs typeface="Tahoma" pitchFamily="34" charset="-120"/>
+                <a:latin typeface="B Nazanin" pitchFamily="34" charset="0"/>
+                <a:ea typeface="B Nazanin" pitchFamily="34" charset="-122"/>
+                <a:cs typeface="B Nazanin" pitchFamily="34" charset="-120"/>
               </a:rPr>
               <a:t>شرکت نسبی</a:t>
             </a:r>
@@ -16318,9 +16266,9 @@
                 <a:solidFill>
                   <a:srgbClr val="1E293B"/>
                 </a:solidFill>
-                <a:latin typeface="Tahoma" pitchFamily="34" charset="0"/>
-                <a:ea typeface="Tahoma" pitchFamily="34" charset="-122"/>
-                <a:cs typeface="Tahoma" pitchFamily="34" charset="-120"/>
+                <a:latin typeface="B Nazanin" pitchFamily="34" charset="0"/>
+                <a:ea typeface="B Nazanin" pitchFamily="34" charset="-122"/>
+                <a:cs typeface="B Nazanin" pitchFamily="34" charset="-120"/>
               </a:rPr>
               <a:t>شبیه تضامنی ولی با یک تفاوت مهم</a:t>
             </a:r>
@@ -16342,9 +16290,9 @@
                 <a:solidFill>
                   <a:srgbClr val="1E293B"/>
                 </a:solidFill>
-                <a:latin typeface="Tahoma" pitchFamily="34" charset="0"/>
-                <a:ea typeface="Tahoma" pitchFamily="34" charset="-122"/>
-                <a:cs typeface="Tahoma" pitchFamily="34" charset="-120"/>
+                <a:latin typeface="B Nazanin" pitchFamily="34" charset="0"/>
+                <a:ea typeface="B Nazanin" pitchFamily="34" charset="-122"/>
+                <a:cs typeface="B Nazanin" pitchFamily="34" charset="-120"/>
               </a:rPr>
               <a:t>مسئولیت هر شریک به نسبت سرمایه‌اش</a:t>
             </a:r>
@@ -16366,9 +16314,9 @@
                 <a:solidFill>
                   <a:srgbClr val="1E293B"/>
                 </a:solidFill>
-                <a:latin typeface="Tahoma" pitchFamily="34" charset="0"/>
-                <a:ea typeface="Tahoma" pitchFamily="34" charset="-122"/>
-                <a:cs typeface="Tahoma" pitchFamily="34" charset="-120"/>
+                <a:latin typeface="B Nazanin" pitchFamily="34" charset="0"/>
+                <a:ea typeface="B Nazanin" pitchFamily="34" charset="-122"/>
+                <a:cs typeface="B Nazanin" pitchFamily="34" charset="-120"/>
               </a:rPr>
               <a:t>مثال: ۳۰٪ سرمایه = ۳۰٪ مسئولیت بدهی</a:t>
             </a:r>
@@ -16390,9 +16338,9 @@
                 <a:solidFill>
                   <a:srgbClr val="1E293B"/>
                 </a:solidFill>
-                <a:latin typeface="Tahoma" pitchFamily="34" charset="0"/>
-                <a:ea typeface="Tahoma" pitchFamily="34" charset="-122"/>
-                <a:cs typeface="Tahoma" pitchFamily="34" charset="-120"/>
+                <a:latin typeface="B Nazanin" pitchFamily="34" charset="0"/>
+                <a:ea typeface="B Nazanin" pitchFamily="34" charset="-122"/>
+                <a:cs typeface="B Nazanin" pitchFamily="34" charset="-120"/>
               </a:rPr>
               <a:t>ریسک کمتر از تضامنی</a:t>
             </a:r>
@@ -16482,9 +16430,9 @@
                 <a:solidFill>
                   <a:srgbClr val="DC2626"/>
                 </a:solidFill>
-                <a:latin typeface="Tahoma" pitchFamily="34" charset="0"/>
-                <a:ea typeface="Tahoma" pitchFamily="34" charset="-122"/>
-                <a:cs typeface="Tahoma" pitchFamily="34" charset="-120"/>
+                <a:latin typeface="B Nazanin" pitchFamily="34" charset="0"/>
+                <a:ea typeface="B Nazanin" pitchFamily="34" charset="-122"/>
+                <a:cs typeface="B Nazanin" pitchFamily="34" charset="-120"/>
               </a:rPr>
               <a:t>⚠  هر دو نوع به دلیل ریسک بالای شرکا، امروزه کمتر مورد استفاده قرار می‌گیرند</a:t>
             </a:r>
@@ -17310,9 +17258,9 @@
                 <a:solidFill>
                   <a:srgbClr val="1E293B"/>
                 </a:solidFill>
-                <a:latin typeface="Tahoma" pitchFamily="34" charset="0"/>
-                <a:ea typeface="Tahoma" pitchFamily="34" charset="-122"/>
-                <a:cs typeface="Tahoma" pitchFamily="34" charset="-120"/>
+                <a:latin typeface="B Titr" pitchFamily="34" charset="0"/>
+                <a:ea typeface="B Titr" pitchFamily="34" charset="-122"/>
+                <a:cs typeface="B Titr" pitchFamily="34" charset="-120"/>
               </a:rPr>
               <a:t>شرکت تعاونی</a:t>
             </a:r>
@@ -17349,9 +17297,9 @@
                 <a:solidFill>
                   <a:srgbClr val="64748B"/>
                 </a:solidFill>
-                <a:latin typeface="Tahoma" pitchFamily="34" charset="0"/>
-                <a:ea typeface="Tahoma" pitchFamily="34" charset="-122"/>
-                <a:cs typeface="Tahoma" pitchFamily="34" charset="-120"/>
+                <a:latin typeface="B Nazanin" pitchFamily="34" charset="0"/>
+                <a:ea typeface="B Nazanin" pitchFamily="34" charset="-122"/>
+                <a:cs typeface="B Nazanin" pitchFamily="34" charset="-120"/>
               </a:rPr>
               <a:t>مشارکت  ◈  دموکراسی  ◈  خدمت به اعضا</a:t>
             </a:r>
@@ -17388,9 +17336,9 @@
                 <a:solidFill>
                   <a:srgbClr val="059669"/>
                 </a:solidFill>
-                <a:latin typeface="Tahoma" pitchFamily="34" charset="0"/>
-                <a:ea typeface="Tahoma" pitchFamily="34" charset="-122"/>
-                <a:cs typeface="Tahoma" pitchFamily="34" charset="-120"/>
+                <a:latin typeface="B Nazanin" pitchFamily="34" charset="0"/>
+                <a:ea typeface="B Nazanin" pitchFamily="34" charset="-122"/>
+                <a:cs typeface="B Nazanin" pitchFamily="34" charset="-120"/>
               </a:rPr>
               <a:t>ویژگی‌های اصلی</a:t>
             </a:r>
@@ -17434,9 +17382,9 @@
                 <a:solidFill>
                   <a:srgbClr val="1E293B"/>
                 </a:solidFill>
-                <a:latin typeface="Tahoma" pitchFamily="34" charset="0"/>
-                <a:ea typeface="Tahoma" pitchFamily="34" charset="-122"/>
-                <a:cs typeface="Tahoma" pitchFamily="34" charset="-120"/>
+                <a:latin typeface="B Nazanin" pitchFamily="34" charset="0"/>
+                <a:ea typeface="B Nazanin" pitchFamily="34" charset="-122"/>
+                <a:cs typeface="B Nazanin" pitchFamily="34" charset="-120"/>
               </a:rPr>
               <a:t>حداقل ۷ عضو نیاز دارد</a:t>
             </a:r>
@@ -17458,9 +17406,9 @@
                 <a:solidFill>
                   <a:srgbClr val="1E293B"/>
                 </a:solidFill>
-                <a:latin typeface="Tahoma" pitchFamily="34" charset="0"/>
-                <a:ea typeface="Tahoma" pitchFamily="34" charset="-122"/>
-                <a:cs typeface="Tahoma" pitchFamily="34" charset="-120"/>
+                <a:latin typeface="B Nazanin" pitchFamily="34" charset="0"/>
+                <a:ea typeface="B Nazanin" pitchFamily="34" charset="-122"/>
+                <a:cs typeface="B Nazanin" pitchFamily="34" charset="-120"/>
               </a:rPr>
               <a:t>هدف: خدمت به اعضا، نه صرفاً سودآوری</a:t>
             </a:r>
@@ -17482,9 +17430,9 @@
                 <a:solidFill>
                   <a:srgbClr val="1E293B"/>
                 </a:solidFill>
-                <a:latin typeface="Tahoma" pitchFamily="34" charset="0"/>
-                <a:ea typeface="Tahoma" pitchFamily="34" charset="-122"/>
-                <a:cs typeface="Tahoma" pitchFamily="34" charset="-120"/>
+                <a:latin typeface="B Nazanin" pitchFamily="34" charset="0"/>
+                <a:ea typeface="B Nazanin" pitchFamily="34" charset="-122"/>
+                <a:cs typeface="B Nazanin" pitchFamily="34" charset="-120"/>
               </a:rPr>
               <a:t>هر عضو = یک رأی (بدون توجه به سرمایه)</a:t>
             </a:r>
@@ -17506,9 +17454,9 @@
                 <a:solidFill>
                   <a:srgbClr val="1E293B"/>
                 </a:solidFill>
-                <a:latin typeface="Tahoma" pitchFamily="34" charset="0"/>
-                <a:ea typeface="Tahoma" pitchFamily="34" charset="-122"/>
-                <a:cs typeface="Tahoma" pitchFamily="34" charset="-120"/>
+                <a:latin typeface="B Nazanin" pitchFamily="34" charset="0"/>
+                <a:ea typeface="B Nazanin" pitchFamily="34" charset="-122"/>
+                <a:cs typeface="B Nazanin" pitchFamily="34" charset="-120"/>
               </a:rPr>
               <a:t>مدیریت دموکراتیک و مشارکتی</a:t>
             </a:r>
@@ -17530,9 +17478,9 @@
                 <a:solidFill>
                   <a:srgbClr val="1E293B"/>
                 </a:solidFill>
-                <a:latin typeface="Tahoma" pitchFamily="34" charset="0"/>
-                <a:ea typeface="Tahoma" pitchFamily="34" charset="-122"/>
-                <a:cs typeface="Tahoma" pitchFamily="34" charset="-120"/>
+                <a:latin typeface="B Nazanin" pitchFamily="34" charset="0"/>
+                <a:ea typeface="B Nazanin" pitchFamily="34" charset="-122"/>
+                <a:cs typeface="B Nazanin" pitchFamily="34" charset="-120"/>
               </a:rPr>
               <a:t>حمایت دولتی و معافیت‌های مالیاتی</a:t>
             </a:r>
@@ -17598,9 +17546,9 @@
                 <a:solidFill>
                   <a:srgbClr val="059669"/>
                 </a:solidFill>
-                <a:latin typeface="Tahoma" pitchFamily="34" charset="0"/>
-                <a:ea typeface="Tahoma" pitchFamily="34" charset="-122"/>
-                <a:cs typeface="Tahoma" pitchFamily="34" charset="-120"/>
+                <a:latin typeface="B Nazanin" pitchFamily="34" charset="0"/>
+                <a:ea typeface="B Nazanin" pitchFamily="34" charset="-122"/>
+                <a:cs typeface="B Nazanin" pitchFamily="34" charset="-120"/>
               </a:rPr>
               <a:t>انواع تعاونی</a:t>
             </a:r>
@@ -17637,9 +17585,9 @@
                 <a:solidFill>
                   <a:srgbClr val="1E293B"/>
                 </a:solidFill>
-                <a:latin typeface="Tahoma" pitchFamily="34" charset="0"/>
-                <a:ea typeface="Tahoma" pitchFamily="34" charset="-122"/>
-                <a:cs typeface="Tahoma" pitchFamily="34" charset="-120"/>
+                <a:latin typeface="B Nazanin" pitchFamily="34" charset="0"/>
+                <a:ea typeface="B Nazanin" pitchFamily="34" charset="-122"/>
+                <a:cs typeface="B Nazanin" pitchFamily="34" charset="-120"/>
               </a:rPr>
               <a:t>▸  تعاونی تولید (مثل کشاورزی)</a:t>
             </a:r>
@@ -17676,9 +17624,9 @@
                 <a:solidFill>
                   <a:srgbClr val="1E293B"/>
                 </a:solidFill>
-                <a:latin typeface="Tahoma" pitchFamily="34" charset="0"/>
-                <a:ea typeface="Tahoma" pitchFamily="34" charset="-122"/>
-                <a:cs typeface="Tahoma" pitchFamily="34" charset="-120"/>
+                <a:latin typeface="B Nazanin" pitchFamily="34" charset="0"/>
+                <a:ea typeface="B Nazanin" pitchFamily="34" charset="-122"/>
+                <a:cs typeface="B Nazanin" pitchFamily="34" charset="-120"/>
               </a:rPr>
               <a:t>▸  تعاونی مصرف (فروشگاه تعاونی)</a:t>
             </a:r>
@@ -17715,9 +17663,9 @@
                 <a:solidFill>
                   <a:srgbClr val="1E293B"/>
                 </a:solidFill>
-                <a:latin typeface="Tahoma" pitchFamily="34" charset="0"/>
-                <a:ea typeface="Tahoma" pitchFamily="34" charset="-122"/>
-                <a:cs typeface="Tahoma" pitchFamily="34" charset="-120"/>
+                <a:latin typeface="B Nazanin" pitchFamily="34" charset="0"/>
+                <a:ea typeface="B Nazanin" pitchFamily="34" charset="-122"/>
+                <a:cs typeface="B Nazanin" pitchFamily="34" charset="-120"/>
               </a:rPr>
               <a:t>▸  تعاونی مسکن</a:t>
             </a:r>
@@ -17783,9 +17731,9 @@
                 <a:solidFill>
                   <a:srgbClr val="059669"/>
                 </a:solidFill>
-                <a:latin typeface="Tahoma" pitchFamily="34" charset="0"/>
-                <a:ea typeface="Tahoma" pitchFamily="34" charset="-122"/>
-                <a:cs typeface="Tahoma" pitchFamily="34" charset="-120"/>
+                <a:latin typeface="B Nazanin" pitchFamily="34" charset="0"/>
+                <a:ea typeface="B Nazanin" pitchFamily="34" charset="-122"/>
+                <a:cs typeface="B Nazanin" pitchFamily="34" charset="-120"/>
               </a:rPr>
               <a:t>مثال کاربردی</a:t>
             </a:r>
@@ -17825,9 +17773,9 @@
                 <a:solidFill>
                   <a:srgbClr val="1E293B"/>
                 </a:solidFill>
-                <a:latin typeface="Tahoma" pitchFamily="34" charset="0"/>
-                <a:ea typeface="Tahoma" pitchFamily="34" charset="-122"/>
-                <a:cs typeface="Tahoma" pitchFamily="34" charset="-120"/>
+                <a:latin typeface="B Nazanin" pitchFamily="34" charset="0"/>
+                <a:ea typeface="B Nazanin" pitchFamily="34" charset="-122"/>
+                <a:cs typeface="B Nazanin" pitchFamily="34" charset="-120"/>
               </a:rPr>
               <a:t>۱۰ کشاورز با هم شرکت تعاونی تشکیل می‌دهند. محصولاتشان را مشترکاً می‌فروشند، قدرت چانه‌زنی بیشتری دارند.</a:t>
             </a:r>
@@ -17888,9 +17836,9 @@
                 <a:solidFill>
                   <a:srgbClr val="059669"/>
                 </a:solidFill>
-                <a:latin typeface="Tahoma" pitchFamily="34" charset="0"/>
-                <a:ea typeface="Tahoma" pitchFamily="34" charset="-122"/>
-                <a:cs typeface="Tahoma" pitchFamily="34" charset="-120"/>
+                <a:latin typeface="B Nazanin" pitchFamily="34" charset="0"/>
+                <a:ea typeface="B Nazanin" pitchFamily="34" charset="-122"/>
+                <a:cs typeface="B Nazanin" pitchFamily="34" charset="-120"/>
               </a:rPr>
               <a:t>اصل اول تعاون:  عضویت داوطلبانه و آزاد  ◈  کنترل دموکراتیک  ◈  تقسیم عادلانه سود</a:t>
             </a:r>
@@ -18896,9 +18844,9 @@
                 <a:solidFill>
                   <a:srgbClr val="1E293B"/>
                 </a:solidFill>
-                <a:latin typeface="Tahoma" pitchFamily="34" charset="0"/>
-                <a:ea typeface="Tahoma" pitchFamily="34" charset="-122"/>
-                <a:cs typeface="Tahoma" pitchFamily="34" charset="-120"/>
+                <a:latin typeface="B Titr" pitchFamily="34" charset="0"/>
+                <a:ea typeface="B Titr" pitchFamily="34" charset="-122"/>
+                <a:cs typeface="B Titr" pitchFamily="34" charset="-120"/>
               </a:rPr>
               <a:t>مقایسه انواع شرکت‌های پرکاربرد</a:t>
             </a:r>
@@ -18949,16 +18897,16 @@
                           <a:solidFill>
                             <a:srgbClr val="FFFFFF"/>
                           </a:solidFill>
-                          <a:latin typeface="Tahoma" pitchFamily="34" charset="0"/>
-                          <a:ea typeface="Tahoma" pitchFamily="34" charset="-122"/>
-                          <a:cs typeface="Tahoma" pitchFamily="34" charset="-120"/>
+                          <a:latin typeface="B Nazanin" pitchFamily="34" charset="0"/>
+                          <a:ea typeface="B Nazanin" pitchFamily="34" charset="-122"/>
+                          <a:cs typeface="B Nazanin" pitchFamily="34" charset="-120"/>
                         </a:rPr>
                         <a:t>مناسب برای</a:t>
                       </a:r>
                       <a:endParaRPr lang="en-US" sz="1200" dirty="0">
-                        <a:latin typeface="Tahoma" charset="0"/>
-                        <a:ea typeface="Tahoma" charset="0"/>
-                        <a:cs typeface="Tahoma" charset="0"/>
+                        <a:latin typeface="B Nazanin" charset="0"/>
+                        <a:ea typeface="B Nazanin" charset="0"/>
+                        <a:cs typeface="B Nazanin" charset="0"/>
                       </a:endParaRPr>
                     </a:p>
                   </a:txBody>
@@ -19017,16 +18965,16 @@
                           <a:solidFill>
                             <a:srgbClr val="FFFFFF"/>
                           </a:solidFill>
-                          <a:latin typeface="Tahoma" pitchFamily="34" charset="0"/>
-                          <a:ea typeface="Tahoma" pitchFamily="34" charset="-122"/>
-                          <a:cs typeface="Tahoma" pitchFamily="34" charset="-120"/>
+                          <a:latin typeface="B Nazanin" pitchFamily="34" charset="0"/>
+                          <a:ea typeface="B Nazanin" pitchFamily="34" charset="-122"/>
+                          <a:cs typeface="B Nazanin" pitchFamily="34" charset="-120"/>
                         </a:rPr>
                         <a:t>مسئولیت شرکا</a:t>
                       </a:r>
                       <a:endParaRPr lang="en-US" sz="1200" dirty="0">
-                        <a:latin typeface="Tahoma" charset="0"/>
-                        <a:ea typeface="Tahoma" charset="0"/>
-                        <a:cs typeface="Tahoma" charset="0"/>
+                        <a:latin typeface="B Nazanin" charset="0"/>
+                        <a:ea typeface="B Nazanin" charset="0"/>
+                        <a:cs typeface="B Nazanin" charset="0"/>
                       </a:endParaRPr>
                     </a:p>
                   </a:txBody>
@@ -19085,16 +19033,16 @@
                           <a:solidFill>
                             <a:srgbClr val="FFFFFF"/>
                           </a:solidFill>
-                          <a:latin typeface="Tahoma" pitchFamily="34" charset="0"/>
-                          <a:ea typeface="Tahoma" pitchFamily="34" charset="-122"/>
-                          <a:cs typeface="Tahoma" pitchFamily="34" charset="-120"/>
+                          <a:latin typeface="B Nazanin" pitchFamily="34" charset="0"/>
+                          <a:ea typeface="B Nazanin" pitchFamily="34" charset="-122"/>
+                          <a:cs typeface="B Nazanin" pitchFamily="34" charset="-120"/>
                         </a:rPr>
                         <a:t>حداقل شرکا</a:t>
                       </a:r>
                       <a:endParaRPr lang="en-US" sz="1200" dirty="0">
-                        <a:latin typeface="Tahoma" charset="0"/>
-                        <a:ea typeface="Tahoma" charset="0"/>
-                        <a:cs typeface="Tahoma" charset="0"/>
+                        <a:latin typeface="B Nazanin" charset="0"/>
+                        <a:ea typeface="B Nazanin" charset="0"/>
+                        <a:cs typeface="B Nazanin" charset="0"/>
                       </a:endParaRPr>
                     </a:p>
                   </a:txBody>
@@ -19153,16 +19101,16 @@
                           <a:solidFill>
                             <a:srgbClr val="FFFFFF"/>
                           </a:solidFill>
-                          <a:latin typeface="Tahoma" pitchFamily="34" charset="0"/>
-                          <a:ea typeface="Tahoma" pitchFamily="34" charset="-122"/>
-                          <a:cs typeface="Tahoma" pitchFamily="34" charset="-120"/>
+                          <a:latin typeface="B Nazanin" pitchFamily="34" charset="0"/>
+                          <a:ea typeface="B Nazanin" pitchFamily="34" charset="-122"/>
+                          <a:cs typeface="B Nazanin" pitchFamily="34" charset="-120"/>
                         </a:rPr>
                         <a:t>حداقل سرمایه</a:t>
                       </a:r>
                       <a:endParaRPr lang="en-US" sz="1200" dirty="0">
-                        <a:latin typeface="Tahoma" charset="0"/>
-                        <a:ea typeface="Tahoma" charset="0"/>
-                        <a:cs typeface="Tahoma" charset="0"/>
+                        <a:latin typeface="B Nazanin" charset="0"/>
+                        <a:ea typeface="B Nazanin" charset="0"/>
+                        <a:cs typeface="B Nazanin" charset="0"/>
                       </a:endParaRPr>
                     </a:p>
                   </a:txBody>
@@ -19221,16 +19169,16 @@
                           <a:solidFill>
                             <a:srgbClr val="FFFFFF"/>
                           </a:solidFill>
-                          <a:latin typeface="Tahoma" pitchFamily="34" charset="0"/>
-                          <a:ea typeface="Tahoma" pitchFamily="34" charset="-122"/>
-                          <a:cs typeface="Tahoma" pitchFamily="34" charset="-120"/>
+                          <a:latin typeface="B Nazanin" pitchFamily="34" charset="0"/>
+                          <a:ea typeface="B Nazanin" pitchFamily="34" charset="-122"/>
+                          <a:cs typeface="B Nazanin" pitchFamily="34" charset="-120"/>
                         </a:rPr>
                         <a:t>نوع شرکت</a:t>
                       </a:r>
                       <a:endParaRPr lang="en-US" sz="1200" dirty="0">
-                        <a:latin typeface="Tahoma" charset="0"/>
-                        <a:ea typeface="Tahoma" charset="0"/>
-                        <a:cs typeface="Tahoma" charset="0"/>
+                        <a:latin typeface="B Nazanin" charset="0"/>
+                        <a:ea typeface="B Nazanin" charset="0"/>
+                        <a:cs typeface="B Nazanin" charset="0"/>
                       </a:endParaRPr>
                     </a:p>
                   </a:txBody>
@@ -19291,16 +19239,16 @@
                           <a:solidFill>
                             <a:srgbClr val="1E293B"/>
                           </a:solidFill>
-                          <a:latin typeface="Tahoma" pitchFamily="34" charset="0"/>
-                          <a:ea typeface="Tahoma" pitchFamily="34" charset="-122"/>
-                          <a:cs typeface="Tahoma" pitchFamily="34" charset="-120"/>
+                          <a:latin typeface="B Nazanin" pitchFamily="34" charset="0"/>
+                          <a:ea typeface="B Nazanin" pitchFamily="34" charset="-122"/>
+                          <a:cs typeface="B Nazanin" pitchFamily="34" charset="-120"/>
                         </a:rPr>
                         <a:t>شرکت‌های بزرگ بورسی</a:t>
                       </a:r>
                       <a:endParaRPr lang="en-US" sz="1100" dirty="0">
-                        <a:latin typeface="Tahoma" charset="0"/>
-                        <a:ea typeface="Tahoma" charset="0"/>
-                        <a:cs typeface="Tahoma" charset="0"/>
+                        <a:latin typeface="B Nazanin" charset="0"/>
+                        <a:ea typeface="B Nazanin" charset="0"/>
+                        <a:cs typeface="B Nazanin" charset="0"/>
                       </a:endParaRPr>
                     </a:p>
                   </a:txBody>
@@ -19359,16 +19307,16 @@
                           <a:solidFill>
                             <a:srgbClr val="059669"/>
                           </a:solidFill>
-                          <a:latin typeface="Tahoma" pitchFamily="34" charset="0"/>
-                          <a:ea typeface="Tahoma" pitchFamily="34" charset="-122"/>
-                          <a:cs typeface="Tahoma" pitchFamily="34" charset="-120"/>
+                          <a:latin typeface="B Nazanin" pitchFamily="34" charset="0"/>
+                          <a:ea typeface="B Nazanin" pitchFamily="34" charset="-122"/>
+                          <a:cs typeface="B Nazanin" pitchFamily="34" charset="-120"/>
                         </a:rPr>
                         <a:t>محدود به سهام</a:t>
                       </a:r>
                       <a:endParaRPr lang="en-US" sz="1100" dirty="0">
-                        <a:latin typeface="Tahoma" charset="0"/>
-                        <a:ea typeface="Tahoma" charset="0"/>
-                        <a:cs typeface="Tahoma" charset="0"/>
+                        <a:latin typeface="B Nazanin" charset="0"/>
+                        <a:ea typeface="B Nazanin" charset="0"/>
+                        <a:cs typeface="B Nazanin" charset="0"/>
                       </a:endParaRPr>
                     </a:p>
                   </a:txBody>
@@ -19427,16 +19375,16 @@
                           <a:solidFill>
                             <a:srgbClr val="1E293B"/>
                           </a:solidFill>
-                          <a:latin typeface="Tahoma" pitchFamily="34" charset="0"/>
-                          <a:ea typeface="Tahoma" pitchFamily="34" charset="-122"/>
-                          <a:cs typeface="Tahoma" pitchFamily="34" charset="-120"/>
+                          <a:latin typeface="B Nazanin" pitchFamily="34" charset="0"/>
+                          <a:ea typeface="B Nazanin" pitchFamily="34" charset="-122"/>
+                          <a:cs typeface="B Nazanin" pitchFamily="34" charset="-120"/>
                         </a:rPr>
                         <a:t>۵ نفر</a:t>
                       </a:r>
                       <a:endParaRPr lang="en-US" sz="1100" dirty="0">
-                        <a:latin typeface="Tahoma" charset="0"/>
-                        <a:ea typeface="Tahoma" charset="0"/>
-                        <a:cs typeface="Tahoma" charset="0"/>
+                        <a:latin typeface="B Nazanin" charset="0"/>
+                        <a:ea typeface="B Nazanin" charset="0"/>
+                        <a:cs typeface="B Nazanin" charset="0"/>
                       </a:endParaRPr>
                     </a:p>
                   </a:txBody>
@@ -19495,16 +19443,16 @@
                           <a:solidFill>
                             <a:srgbClr val="1E293B"/>
                           </a:solidFill>
-                          <a:latin typeface="Tahoma" pitchFamily="34" charset="0"/>
-                          <a:ea typeface="Tahoma" pitchFamily="34" charset="-122"/>
-                          <a:cs typeface="Tahoma" pitchFamily="34" charset="-120"/>
+                          <a:latin typeface="B Nazanin" pitchFamily="34" charset="0"/>
+                          <a:ea typeface="B Nazanin" pitchFamily="34" charset="-122"/>
+                          <a:cs typeface="B Nazanin" pitchFamily="34" charset="-120"/>
                         </a:rPr>
                         <a:t>بالا</a:t>
                       </a:r>
                       <a:endParaRPr lang="en-US" sz="1100" dirty="0">
-                        <a:latin typeface="Tahoma" charset="0"/>
-                        <a:ea typeface="Tahoma" charset="0"/>
-                        <a:cs typeface="Tahoma" charset="0"/>
+                        <a:latin typeface="B Nazanin" charset="0"/>
+                        <a:ea typeface="B Nazanin" charset="0"/>
+                        <a:cs typeface="B Nazanin" charset="0"/>
                       </a:endParaRPr>
                     </a:p>
                   </a:txBody>
@@ -19563,16 +19511,16 @@
                           <a:solidFill>
                             <a:srgbClr val="7C3AED"/>
                           </a:solidFill>
-                          <a:latin typeface="Tahoma" pitchFamily="34" charset="0"/>
-                          <a:ea typeface="Tahoma" pitchFamily="34" charset="-122"/>
-                          <a:cs typeface="Tahoma" pitchFamily="34" charset="-120"/>
+                          <a:latin typeface="B Nazanin" pitchFamily="34" charset="0"/>
+                          <a:ea typeface="B Nazanin" pitchFamily="34" charset="-122"/>
+                          <a:cs typeface="B Nazanin" pitchFamily="34" charset="-120"/>
                         </a:rPr>
                         <a:t>سهامی عام</a:t>
                       </a:r>
                       <a:endParaRPr lang="en-US" sz="1100" dirty="0">
-                        <a:latin typeface="Tahoma" charset="0"/>
-                        <a:ea typeface="Tahoma" charset="0"/>
-                        <a:cs typeface="Tahoma" charset="0"/>
+                        <a:latin typeface="B Nazanin" charset="0"/>
+                        <a:ea typeface="B Nazanin" charset="0"/>
+                        <a:cs typeface="B Nazanin" charset="0"/>
                       </a:endParaRPr>
                     </a:p>
                   </a:txBody>
@@ -19633,16 +19581,16 @@
                           <a:solidFill>
                             <a:srgbClr val="1E293B"/>
                           </a:solidFill>
-                          <a:latin typeface="Tahoma" pitchFamily="34" charset="0"/>
-                          <a:ea typeface="Tahoma" pitchFamily="34" charset="-122"/>
-                          <a:cs typeface="Tahoma" pitchFamily="34" charset="-120"/>
+                          <a:latin typeface="B Nazanin" pitchFamily="34" charset="0"/>
+                          <a:ea typeface="B Nazanin" pitchFamily="34" charset="-122"/>
+                          <a:cs typeface="B Nazanin" pitchFamily="34" charset="-120"/>
                         </a:rPr>
                         <a:t>استارتاپ و شرکت متوسط</a:t>
                       </a:r>
                       <a:endParaRPr lang="en-US" sz="1100" dirty="0">
-                        <a:latin typeface="Tahoma" charset="0"/>
-                        <a:ea typeface="Tahoma" charset="0"/>
-                        <a:cs typeface="Tahoma" charset="0"/>
+                        <a:latin typeface="B Nazanin" charset="0"/>
+                        <a:ea typeface="B Nazanin" charset="0"/>
+                        <a:cs typeface="B Nazanin" charset="0"/>
                       </a:endParaRPr>
                     </a:p>
                   </a:txBody>
@@ -19701,16 +19649,16 @@
                           <a:solidFill>
                             <a:srgbClr val="059669"/>
                           </a:solidFill>
-                          <a:latin typeface="Tahoma" pitchFamily="34" charset="0"/>
-                          <a:ea typeface="Tahoma" pitchFamily="34" charset="-122"/>
-                          <a:cs typeface="Tahoma" pitchFamily="34" charset="-120"/>
+                          <a:latin typeface="B Nazanin" pitchFamily="34" charset="0"/>
+                          <a:ea typeface="B Nazanin" pitchFamily="34" charset="-122"/>
+                          <a:cs typeface="B Nazanin" pitchFamily="34" charset="-120"/>
                         </a:rPr>
                         <a:t>محدود به سهام</a:t>
                       </a:r>
                       <a:endParaRPr lang="en-US" sz="1100" dirty="0">
-                        <a:latin typeface="Tahoma" charset="0"/>
-                        <a:ea typeface="Tahoma" charset="0"/>
-                        <a:cs typeface="Tahoma" charset="0"/>
+                        <a:latin typeface="B Nazanin" charset="0"/>
+                        <a:ea typeface="B Nazanin" charset="0"/>
+                        <a:cs typeface="B Nazanin" charset="0"/>
                       </a:endParaRPr>
                     </a:p>
                   </a:txBody>
@@ -19769,16 +19717,16 @@
                           <a:solidFill>
                             <a:srgbClr val="1E293B"/>
                           </a:solidFill>
-                          <a:latin typeface="Tahoma" pitchFamily="34" charset="0"/>
-                          <a:ea typeface="Tahoma" pitchFamily="34" charset="-122"/>
-                          <a:cs typeface="Tahoma" pitchFamily="34" charset="-120"/>
+                          <a:latin typeface="B Nazanin" pitchFamily="34" charset="0"/>
+                          <a:ea typeface="B Nazanin" pitchFamily="34" charset="-122"/>
+                          <a:cs typeface="B Nazanin" pitchFamily="34" charset="-120"/>
                         </a:rPr>
                         <a:t>۳ نفر</a:t>
                       </a:r>
                       <a:endParaRPr lang="en-US" sz="1100" dirty="0">
-                        <a:latin typeface="Tahoma" charset="0"/>
-                        <a:ea typeface="Tahoma" charset="0"/>
-                        <a:cs typeface="Tahoma" charset="0"/>
+                        <a:latin typeface="B Nazanin" charset="0"/>
+                        <a:ea typeface="B Nazanin" charset="0"/>
+                        <a:cs typeface="B Nazanin" charset="0"/>
                       </a:endParaRPr>
                     </a:p>
                   </a:txBody>
@@ -19837,16 +19785,16 @@
                           <a:solidFill>
                             <a:srgbClr val="1E293B"/>
                           </a:solidFill>
-                          <a:latin typeface="Tahoma" pitchFamily="34" charset="0"/>
-                          <a:ea typeface="Tahoma" pitchFamily="34" charset="-122"/>
-                          <a:cs typeface="Tahoma" pitchFamily="34" charset="-120"/>
+                          <a:latin typeface="B Nazanin" pitchFamily="34" charset="0"/>
+                          <a:ea typeface="B Nazanin" pitchFamily="34" charset="-122"/>
+                          <a:cs typeface="B Nazanin" pitchFamily="34" charset="-120"/>
                         </a:rPr>
                         <a:t>کم</a:t>
                       </a:r>
                       <a:endParaRPr lang="en-US" sz="1100" dirty="0">
-                        <a:latin typeface="Tahoma" charset="0"/>
-                        <a:ea typeface="Tahoma" charset="0"/>
-                        <a:cs typeface="Tahoma" charset="0"/>
+                        <a:latin typeface="B Nazanin" charset="0"/>
+                        <a:ea typeface="B Nazanin" charset="0"/>
+                        <a:cs typeface="B Nazanin" charset="0"/>
                       </a:endParaRPr>
                     </a:p>
                   </a:txBody>
@@ -19905,16 +19853,16 @@
                           <a:solidFill>
                             <a:srgbClr val="2563EB"/>
                           </a:solidFill>
-                          <a:latin typeface="Tahoma" pitchFamily="34" charset="0"/>
-                          <a:ea typeface="Tahoma" pitchFamily="34" charset="-122"/>
-                          <a:cs typeface="Tahoma" pitchFamily="34" charset="-120"/>
+                          <a:latin typeface="B Nazanin" pitchFamily="34" charset="0"/>
+                          <a:ea typeface="B Nazanin" pitchFamily="34" charset="-122"/>
+                          <a:cs typeface="B Nazanin" pitchFamily="34" charset="-120"/>
                         </a:rPr>
                         <a:t>سهامی خاص</a:t>
                       </a:r>
                       <a:endParaRPr lang="en-US" sz="1100" dirty="0">
-                        <a:latin typeface="Tahoma" charset="0"/>
-                        <a:ea typeface="Tahoma" charset="0"/>
-                        <a:cs typeface="Tahoma" charset="0"/>
+                        <a:latin typeface="B Nazanin" charset="0"/>
+                        <a:ea typeface="B Nazanin" charset="0"/>
+                        <a:cs typeface="B Nazanin" charset="0"/>
                       </a:endParaRPr>
                     </a:p>
                   </a:txBody>
@@ -19975,16 +19923,16 @@
                           <a:solidFill>
                             <a:srgbClr val="1E293B"/>
                           </a:solidFill>
-                          <a:latin typeface="Tahoma" pitchFamily="34" charset="0"/>
-                          <a:ea typeface="Tahoma" pitchFamily="34" charset="-122"/>
-                          <a:cs typeface="Tahoma" pitchFamily="34" charset="-120"/>
+                          <a:latin typeface="B Nazanin" pitchFamily="34" charset="0"/>
+                          <a:ea typeface="B Nazanin" pitchFamily="34" charset="-122"/>
+                          <a:cs typeface="B Nazanin" pitchFamily="34" charset="-120"/>
                         </a:rPr>
                         <a:t>کسب‌وکار کوچک خانوادگی</a:t>
                       </a:r>
                       <a:endParaRPr lang="en-US" sz="1100" dirty="0">
-                        <a:latin typeface="Tahoma" charset="0"/>
-                        <a:ea typeface="Tahoma" charset="0"/>
-                        <a:cs typeface="Tahoma" charset="0"/>
+                        <a:latin typeface="B Nazanin" charset="0"/>
+                        <a:ea typeface="B Nazanin" charset="0"/>
+                        <a:cs typeface="B Nazanin" charset="0"/>
                       </a:endParaRPr>
                     </a:p>
                   </a:txBody>
@@ -20043,16 +19991,16 @@
                           <a:solidFill>
                             <a:srgbClr val="059669"/>
                           </a:solidFill>
-                          <a:latin typeface="Tahoma" pitchFamily="34" charset="0"/>
-                          <a:ea typeface="Tahoma" pitchFamily="34" charset="-122"/>
-                          <a:cs typeface="Tahoma" pitchFamily="34" charset="-120"/>
+                          <a:latin typeface="B Nazanin" pitchFamily="34" charset="0"/>
+                          <a:ea typeface="B Nazanin" pitchFamily="34" charset="-122"/>
+                          <a:cs typeface="B Nazanin" pitchFamily="34" charset="-120"/>
                         </a:rPr>
                         <a:t>محدود به سهم‌الشرکه</a:t>
                       </a:r>
                       <a:endParaRPr lang="en-US" sz="1100" dirty="0">
-                        <a:latin typeface="Tahoma" charset="0"/>
-                        <a:ea typeface="Tahoma" charset="0"/>
-                        <a:cs typeface="Tahoma" charset="0"/>
+                        <a:latin typeface="B Nazanin" charset="0"/>
+                        <a:ea typeface="B Nazanin" charset="0"/>
+                        <a:cs typeface="B Nazanin" charset="0"/>
                       </a:endParaRPr>
                     </a:p>
                   </a:txBody>
@@ -20111,16 +20059,16 @@
                           <a:solidFill>
                             <a:srgbClr val="1E293B"/>
                           </a:solidFill>
-                          <a:latin typeface="Tahoma" pitchFamily="34" charset="0"/>
-                          <a:ea typeface="Tahoma" pitchFamily="34" charset="-122"/>
-                          <a:cs typeface="Tahoma" pitchFamily="34" charset="-120"/>
+                          <a:latin typeface="B Nazanin" pitchFamily="34" charset="0"/>
+                          <a:ea typeface="B Nazanin" pitchFamily="34" charset="-122"/>
+                          <a:cs typeface="B Nazanin" pitchFamily="34" charset="-120"/>
                         </a:rPr>
                         <a:t>۲ نفر</a:t>
                       </a:r>
                       <a:endParaRPr lang="en-US" sz="1100" dirty="0">
-                        <a:latin typeface="Tahoma" charset="0"/>
-                        <a:ea typeface="Tahoma" charset="0"/>
-                        <a:cs typeface="Tahoma" charset="0"/>
+                        <a:latin typeface="B Nazanin" charset="0"/>
+                        <a:ea typeface="B Nazanin" charset="0"/>
+                        <a:cs typeface="B Nazanin" charset="0"/>
                       </a:endParaRPr>
                     </a:p>
                   </a:txBody>
@@ -20179,16 +20127,16 @@
                           <a:solidFill>
                             <a:srgbClr val="1E293B"/>
                           </a:solidFill>
-                          <a:latin typeface="Tahoma" pitchFamily="34" charset="0"/>
-                          <a:ea typeface="Tahoma" pitchFamily="34" charset="-122"/>
-                          <a:cs typeface="Tahoma" pitchFamily="34" charset="-120"/>
+                          <a:latin typeface="B Nazanin" pitchFamily="34" charset="0"/>
+                          <a:ea typeface="B Nazanin" pitchFamily="34" charset="-122"/>
+                          <a:cs typeface="B Nazanin" pitchFamily="34" charset="-120"/>
                         </a:rPr>
                         <a:t>بدون حداقل</a:t>
                       </a:r>
                       <a:endParaRPr lang="en-US" sz="1100" dirty="0">
-                        <a:latin typeface="Tahoma" charset="0"/>
-                        <a:ea typeface="Tahoma" charset="0"/>
-                        <a:cs typeface="Tahoma" charset="0"/>
+                        <a:latin typeface="B Nazanin" charset="0"/>
+                        <a:ea typeface="B Nazanin" charset="0"/>
+                        <a:cs typeface="B Nazanin" charset="0"/>
                       </a:endParaRPr>
                     </a:p>
                   </a:txBody>
@@ -20247,16 +20195,16 @@
                           <a:solidFill>
                             <a:srgbClr val="0891B2"/>
                           </a:solidFill>
-                          <a:latin typeface="Tahoma" pitchFamily="34" charset="0"/>
-                          <a:ea typeface="Tahoma" pitchFamily="34" charset="-122"/>
-                          <a:cs typeface="Tahoma" pitchFamily="34" charset="-120"/>
+                          <a:latin typeface="B Nazanin" pitchFamily="34" charset="0"/>
+                          <a:ea typeface="B Nazanin" pitchFamily="34" charset="-122"/>
+                          <a:cs typeface="B Nazanin" pitchFamily="34" charset="-120"/>
                         </a:rPr>
                         <a:t>مسئولیت محدود</a:t>
                       </a:r>
                       <a:endParaRPr lang="en-US" sz="1100" dirty="0">
-                        <a:latin typeface="Tahoma" charset="0"/>
-                        <a:ea typeface="Tahoma" charset="0"/>
-                        <a:cs typeface="Tahoma" charset="0"/>
+                        <a:latin typeface="B Nazanin" charset="0"/>
+                        <a:ea typeface="B Nazanin" charset="0"/>
+                        <a:cs typeface="B Nazanin" charset="0"/>
                       </a:endParaRPr>
                     </a:p>
                   </a:txBody>
@@ -20317,16 +20265,16 @@
                           <a:solidFill>
                             <a:srgbClr val="1E293B"/>
                           </a:solidFill>
-                          <a:latin typeface="Tahoma" pitchFamily="34" charset="0"/>
-                          <a:ea typeface="Tahoma" pitchFamily="34" charset="-122"/>
-                          <a:cs typeface="Tahoma" pitchFamily="34" charset="-120"/>
+                          <a:latin typeface="B Nazanin" pitchFamily="34" charset="0"/>
+                          <a:ea typeface="B Nazanin" pitchFamily="34" charset="-122"/>
+                          <a:cs typeface="B Nazanin" pitchFamily="34" charset="-120"/>
                         </a:rPr>
                         <a:t>فعالیت مبتنی بر اعتماد</a:t>
                       </a:r>
                       <a:endParaRPr lang="en-US" sz="1100" dirty="0">
-                        <a:latin typeface="Tahoma" charset="0"/>
-                        <a:ea typeface="Tahoma" charset="0"/>
-                        <a:cs typeface="Tahoma" charset="0"/>
+                        <a:latin typeface="B Nazanin" charset="0"/>
+                        <a:ea typeface="B Nazanin" charset="0"/>
+                        <a:cs typeface="B Nazanin" charset="0"/>
                       </a:endParaRPr>
                     </a:p>
                   </a:txBody>
@@ -20385,16 +20333,16 @@
                           <a:solidFill>
                             <a:srgbClr val="DC2626"/>
                           </a:solidFill>
-                          <a:latin typeface="Tahoma" pitchFamily="34" charset="0"/>
-                          <a:ea typeface="Tahoma" pitchFamily="34" charset="-122"/>
-                          <a:cs typeface="Tahoma" pitchFamily="34" charset="-120"/>
+                          <a:latin typeface="B Nazanin" pitchFamily="34" charset="0"/>
+                          <a:ea typeface="B Nazanin" pitchFamily="34" charset="-122"/>
+                          <a:cs typeface="B Nazanin" pitchFamily="34" charset="-120"/>
                         </a:rPr>
                         <a:t>نامحدود</a:t>
                       </a:r>
                       <a:endParaRPr lang="en-US" sz="1100" dirty="0">
-                        <a:latin typeface="Tahoma" charset="0"/>
-                        <a:ea typeface="Tahoma" charset="0"/>
-                        <a:cs typeface="Tahoma" charset="0"/>
+                        <a:latin typeface="B Nazanin" charset="0"/>
+                        <a:ea typeface="B Nazanin" charset="0"/>
+                        <a:cs typeface="B Nazanin" charset="0"/>
                       </a:endParaRPr>
                     </a:p>
                   </a:txBody>
@@ -20453,16 +20401,16 @@
                           <a:solidFill>
                             <a:srgbClr val="1E293B"/>
                           </a:solidFill>
-                          <a:latin typeface="Tahoma" pitchFamily="34" charset="0"/>
-                          <a:ea typeface="Tahoma" pitchFamily="34" charset="-122"/>
-                          <a:cs typeface="Tahoma" pitchFamily="34" charset="-120"/>
+                          <a:latin typeface="B Nazanin" pitchFamily="34" charset="0"/>
+                          <a:ea typeface="B Nazanin" pitchFamily="34" charset="-122"/>
+                          <a:cs typeface="B Nazanin" pitchFamily="34" charset="-120"/>
                         </a:rPr>
                         <a:t>۲ نفر</a:t>
                       </a:r>
                       <a:endParaRPr lang="en-US" sz="1100" dirty="0">
-                        <a:latin typeface="Tahoma" charset="0"/>
-                        <a:ea typeface="Tahoma" charset="0"/>
-                        <a:cs typeface="Tahoma" charset="0"/>
+                        <a:latin typeface="B Nazanin" charset="0"/>
+                        <a:ea typeface="B Nazanin" charset="0"/>
+                        <a:cs typeface="B Nazanin" charset="0"/>
                       </a:endParaRPr>
                     </a:p>
                   </a:txBody>
@@ -20521,16 +20469,16 @@
                           <a:solidFill>
                             <a:srgbClr val="1E293B"/>
                           </a:solidFill>
-                          <a:latin typeface="Tahoma" pitchFamily="34" charset="0"/>
-                          <a:ea typeface="Tahoma" pitchFamily="34" charset="-122"/>
-                          <a:cs typeface="Tahoma" pitchFamily="34" charset="-120"/>
+                          <a:latin typeface="B Nazanin" pitchFamily="34" charset="0"/>
+                          <a:ea typeface="B Nazanin" pitchFamily="34" charset="-122"/>
+                          <a:cs typeface="B Nazanin" pitchFamily="34" charset="-120"/>
                         </a:rPr>
                         <a:t>مشخص نشده</a:t>
                       </a:r>
                       <a:endParaRPr lang="en-US" sz="1100" dirty="0">
-                        <a:latin typeface="Tahoma" charset="0"/>
-                        <a:ea typeface="Tahoma" charset="0"/>
-                        <a:cs typeface="Tahoma" charset="0"/>
+                        <a:latin typeface="B Nazanin" charset="0"/>
+                        <a:ea typeface="B Nazanin" charset="0"/>
+                        <a:cs typeface="B Nazanin" charset="0"/>
                       </a:endParaRPr>
                     </a:p>
                   </a:txBody>
@@ -20589,16 +20537,16 @@
                           <a:solidFill>
                             <a:srgbClr val="DC2626"/>
                           </a:solidFill>
-                          <a:latin typeface="Tahoma" pitchFamily="34" charset="0"/>
-                          <a:ea typeface="Tahoma" pitchFamily="34" charset="-122"/>
-                          <a:cs typeface="Tahoma" pitchFamily="34" charset="-120"/>
+                          <a:latin typeface="B Nazanin" pitchFamily="34" charset="0"/>
+                          <a:ea typeface="B Nazanin" pitchFamily="34" charset="-122"/>
+                          <a:cs typeface="B Nazanin" pitchFamily="34" charset="-120"/>
                         </a:rPr>
                         <a:t>تضامنی</a:t>
                       </a:r>
                       <a:endParaRPr lang="en-US" sz="1100" dirty="0">
-                        <a:latin typeface="Tahoma" charset="0"/>
-                        <a:ea typeface="Tahoma" charset="0"/>
-                        <a:cs typeface="Tahoma" charset="0"/>
+                        <a:latin typeface="B Nazanin" charset="0"/>
+                        <a:ea typeface="B Nazanin" charset="0"/>
+                        <a:cs typeface="B Nazanin" charset="0"/>
                       </a:endParaRPr>
                     </a:p>
                   </a:txBody>
@@ -20659,16 +20607,16 @@
                           <a:solidFill>
                             <a:srgbClr val="1E293B"/>
                           </a:solidFill>
-                          <a:latin typeface="Tahoma" pitchFamily="34" charset="0"/>
-                          <a:ea typeface="Tahoma" pitchFamily="34" charset="-122"/>
-                          <a:cs typeface="Tahoma" pitchFamily="34" charset="-120"/>
+                          <a:latin typeface="B Nazanin" pitchFamily="34" charset="0"/>
+                          <a:ea typeface="B Nazanin" pitchFamily="34" charset="-122"/>
+                          <a:cs typeface="B Nazanin" pitchFamily="34" charset="-120"/>
                         </a:rPr>
                         <a:t>فعالیت‌های مشارکتی</a:t>
                       </a:r>
                       <a:endParaRPr lang="en-US" sz="1100" dirty="0">
-                        <a:latin typeface="Tahoma" charset="0"/>
-                        <a:ea typeface="Tahoma" charset="0"/>
-                        <a:cs typeface="Tahoma" charset="0"/>
+                        <a:latin typeface="B Nazanin" charset="0"/>
+                        <a:ea typeface="B Nazanin" charset="0"/>
+                        <a:cs typeface="B Nazanin" charset="0"/>
                       </a:endParaRPr>
                     </a:p>
                   </a:txBody>
@@ -20727,16 +20675,16 @@
                           <a:solidFill>
                             <a:srgbClr val="059669"/>
                           </a:solidFill>
-                          <a:latin typeface="Tahoma" pitchFamily="34" charset="0"/>
-                          <a:ea typeface="Tahoma" pitchFamily="34" charset="-122"/>
-                          <a:cs typeface="Tahoma" pitchFamily="34" charset="-120"/>
+                          <a:latin typeface="B Nazanin" pitchFamily="34" charset="0"/>
+                          <a:ea typeface="B Nazanin" pitchFamily="34" charset="-122"/>
+                          <a:cs typeface="B Nazanin" pitchFamily="34" charset="-120"/>
                         </a:rPr>
                         <a:t>محدود</a:t>
                       </a:r>
                       <a:endParaRPr lang="en-US" sz="1100" dirty="0">
-                        <a:latin typeface="Tahoma" charset="0"/>
-                        <a:ea typeface="Tahoma" charset="0"/>
-                        <a:cs typeface="Tahoma" charset="0"/>
+                        <a:latin typeface="B Nazanin" charset="0"/>
+                        <a:ea typeface="B Nazanin" charset="0"/>
+                        <a:cs typeface="B Nazanin" charset="0"/>
                       </a:endParaRPr>
                     </a:p>
                   </a:txBody>
@@ -20795,16 +20743,16 @@
                           <a:solidFill>
                             <a:srgbClr val="1E293B"/>
                           </a:solidFill>
-                          <a:latin typeface="Tahoma" pitchFamily="34" charset="0"/>
-                          <a:ea typeface="Tahoma" pitchFamily="34" charset="-122"/>
-                          <a:cs typeface="Tahoma" pitchFamily="34" charset="-120"/>
+                          <a:latin typeface="B Nazanin" pitchFamily="34" charset="0"/>
+                          <a:ea typeface="B Nazanin" pitchFamily="34" charset="-122"/>
+                          <a:cs typeface="B Nazanin" pitchFamily="34" charset="-120"/>
                         </a:rPr>
                         <a:t>۷ نفر</a:t>
                       </a:r>
                       <a:endParaRPr lang="en-US" sz="1100" dirty="0">
-                        <a:latin typeface="Tahoma" charset="0"/>
-                        <a:ea typeface="Tahoma" charset="0"/>
-                        <a:cs typeface="Tahoma" charset="0"/>
+                        <a:latin typeface="B Nazanin" charset="0"/>
+                        <a:ea typeface="B Nazanin" charset="0"/>
+                        <a:cs typeface="B Nazanin" charset="0"/>
                       </a:endParaRPr>
                     </a:p>
                   </a:txBody>
@@ -20863,16 +20811,16 @@
                           <a:solidFill>
                             <a:srgbClr val="1E293B"/>
                           </a:solidFill>
-                          <a:latin typeface="Tahoma" pitchFamily="34" charset="0"/>
-                          <a:ea typeface="Tahoma" pitchFamily="34" charset="-122"/>
-                          <a:cs typeface="Tahoma" pitchFamily="34" charset="-120"/>
+                          <a:latin typeface="B Nazanin" pitchFamily="34" charset="0"/>
+                          <a:ea typeface="B Nazanin" pitchFamily="34" charset="-122"/>
+                          <a:cs typeface="B Nazanin" pitchFamily="34" charset="-120"/>
                         </a:rPr>
                         <a:t>متغیر</a:t>
                       </a:r>
                       <a:endParaRPr lang="en-US" sz="1100" dirty="0">
-                        <a:latin typeface="Tahoma" charset="0"/>
-                        <a:ea typeface="Tahoma" charset="0"/>
-                        <a:cs typeface="Tahoma" charset="0"/>
+                        <a:latin typeface="B Nazanin" charset="0"/>
+                        <a:ea typeface="B Nazanin" charset="0"/>
+                        <a:cs typeface="B Nazanin" charset="0"/>
                       </a:endParaRPr>
                     </a:p>
                   </a:txBody>
@@ -20931,16 +20879,16 @@
                           <a:solidFill>
                             <a:srgbClr val="059669"/>
                           </a:solidFill>
-                          <a:latin typeface="Tahoma" pitchFamily="34" charset="0"/>
-                          <a:ea typeface="Tahoma" pitchFamily="34" charset="-122"/>
-                          <a:cs typeface="Tahoma" pitchFamily="34" charset="-120"/>
+                          <a:latin typeface="B Nazanin" pitchFamily="34" charset="0"/>
+                          <a:ea typeface="B Nazanin" pitchFamily="34" charset="-122"/>
+                          <a:cs typeface="B Nazanin" pitchFamily="34" charset="-120"/>
                         </a:rPr>
                         <a:t>تعاونی</a:t>
                       </a:r>
                       <a:endParaRPr lang="en-US" sz="1100" dirty="0">
-                        <a:latin typeface="Tahoma" charset="0"/>
-                        <a:ea typeface="Tahoma" charset="0"/>
-                        <a:cs typeface="Tahoma" charset="0"/>
+                        <a:latin typeface="B Nazanin" charset="0"/>
+                        <a:ea typeface="B Nazanin" charset="0"/>
+                        <a:cs typeface="B Nazanin" charset="0"/>
                       </a:endParaRPr>
                     </a:p>
                   </a:txBody>
@@ -21044,9 +20992,9 @@
                 <a:solidFill>
                   <a:srgbClr val="059669"/>
                 </a:solidFill>
-                <a:latin typeface="Tahoma" pitchFamily="34" charset="0"/>
-                <a:ea typeface="Tahoma" pitchFamily="34" charset="-122"/>
-                <a:cs typeface="Tahoma" pitchFamily="34" charset="-120"/>
+                <a:latin typeface="B Nazanin" pitchFamily="34" charset="0"/>
+                <a:ea typeface="B Nazanin" pitchFamily="34" charset="-122"/>
+                <a:cs typeface="B Nazanin" pitchFamily="34" charset="-120"/>
               </a:rPr>
               <a:t>✔  برای اکثر کارآفرینان: «سهامی خاص» یا «مسئولیت محدود» بهترین انتخاب است</a:t>
             </a:r>
@@ -21526,7 +21474,7 @@
     </a:clrScheme>
     <a:fontScheme name="Tejarat">
       <a:majorFont>
-        <a:latin typeface="Tahoma"/>
+        <a:latin typeface="B Titr"/>
         <a:ea typeface=""/>
         <a:cs typeface=""/>
         <a:font script="Jpan" typeface="游ゴシック Light"/>
@@ -21578,7 +21526,7 @@
         <a:font script="Tfng" typeface="Ebrima"/>
       </a:majorFont>
       <a:minorFont>
-        <a:latin typeface="Tahoma"/>
+        <a:latin typeface="B Nazanin"/>
         <a:ea typeface=""/>
         <a:cs typeface=""/>
         <a:font script="Jpan" typeface="游ゴシック"/>

</xml_diff>